<commit_message>
Add author photos and other books to presentation biography
Co-Authored-By: Claude Opus 5.5 <noreply@anthropic.com>
Claude-Session: https://claude.ai/code/session_01LyAEdHGJyBVYLz5Wq2uw9J
</commit_message>
<xml_diff>
--- a/PPT_Review_of_Commando_Winning_the_Green_Beret.pptx
+++ b/PPT_Review_of_Commando_Winning_the_Green_Beret.pptx
@@ -36,6 +36,8 @@
     <p:sldId id="278" r:id="rId4"/>
     <p:sldId id="279" r:id="rId3"/>
     <p:sldId id="280" r:id="rId2"/>
+    <p:sldId id="281" r:id="rId34"/>
+    <p:sldId id="282" r:id="rId35"/>
   </p:sldIdLst>
   <p:sldSz cx="12192000" cy="6858000"/>
   <p:notesSz cx="6858000" cy="9144000"/>
@@ -827,7 +829,7 @@
           <a:lstStyle/>
           <a:p>
             <a:r>
-              <a:t>For military officers, these lessons underline the need to build mental toughness deliberately into training and to enforce standards of personal discipline. Soldiers, sailors and airmen who pass the same tests as the Royal Marines earn the trust of the formation they join.</a:t>
+              <a:t>Significance: one of the most authoritative insider accounts of commando selection; shows how a respected institution turns ordinary young men into elite amphibious soldiers. Materials: entirely original, drawn from first-hand observation and the recorded words of recruits and instructors; opens doors normally closed to outsiders. Facts: test standards, numbers and dates recorded with precision; the Commandant and training teams read the chapters before publication. Clarity: logical sequence building to the Commando Tests; terms explained as they arise; organisation chart, endurance course diagram and captioned photographs. Readability: present-tense, documentary immediacy; vivid scenes and lively dialogue make it a page-turner. Mental stimulation: real dilemmas of selection, standards and integrity invite the reader to ask what he would have done. Broad-mindedness: every voice is heard, from recruit to Commandant; failures are treated with dignity. Inspiration: Jaftha’s perseverance, and leaders such as Colonel Taffinder, Major Lear and Captain Williams who take hard decisions with fairness.</a:t>
             </a:r>
           </a:p>
         </p:txBody>
@@ -897,7 +899,7 @@
           <a:lstStyle/>
           <a:p>
             <a:r>
-              <a:t>The instructors and commanders portrayed in the book know their men and take difficult decisions with both rigour and compassion. Detailed orders and rehearsals kept the Portland raid on track when the radios failed, while lapses of honesty were dealt with severely.</a:t>
+              <a:t>For military officers, these lessons underline the need to build mental toughness deliberately into training and to enforce standards of personal discipline. Soldiers, sailors and airmen who pass the same tests as the Royal Marines earn the trust of the formation they join.</a:t>
             </a:r>
           </a:p>
         </p:txBody>
@@ -967,6 +969,76 @@
           <a:lstStyle/>
           <a:p>
             <a:r>
+              <a:t>The instructors and commanders portrayed in the book know their men and take difficult decisions with both rigour and compassion. Detailed orders and rehearsals kept the Portland raid on track when the radios failed, while lapses of honesty were dealt with severely.</a:t>
+            </a:r>
+          </a:p>
+        </p:txBody>
+      </p:sp>
+      <p:sp>
+        <p:nvSpPr>
+          <p:cNvPr id="4" name="Slide Number Placeholder 3"/>
+          <p:cNvSpPr>
+            <a:spLocks noGrp="1"/>
+          </p:cNvSpPr>
+          <p:nvPr>
+            <p:ph type="sldNum" idx="5" sz="quarter"/>
+          </p:nvPr>
+        </p:nvSpPr>
+        <p:spPr/>
+      </p:sp>
+    </p:spTree>
+  </p:cSld>
+  <p:clrMapOvr>
+    <a:masterClrMapping/>
+  </p:clrMapOvr>
+</p:notes>
+</file>
+
+<file path=ppt/notesSlides/notesSlide13.xml><?xml version="1.0" encoding="utf-8"?>
+<p:notes xmlns:a="http://schemas.openxmlformats.org/drawingml/2006/main" xmlns:p="http://schemas.openxmlformats.org/presentationml/2006/main" xmlns:r="http://schemas.openxmlformats.org/officeDocument/2006/relationships">
+  <p:cSld>
+    <p:spTree>
+      <p:nvGrpSpPr>
+        <p:cNvPr id="1" name=""/>
+        <p:cNvGrpSpPr/>
+        <p:nvPr/>
+      </p:nvGrpSpPr>
+      <p:grpSpPr>
+        <a:xfrm>
+          <a:off x="0" y="0"/>
+          <a:ext cx="0" cy="0"/>
+          <a:chOff x="0" y="0"/>
+          <a:chExt cx="0" cy="0"/>
+        </a:xfrm>
+      </p:grpSpPr>
+      <p:sp>
+        <p:nvSpPr>
+          <p:cNvPr id="2" name="Slide Image Placeholder 1"/>
+          <p:cNvSpPr>
+            <a:spLocks noGrp="1"/>
+          </p:cNvSpPr>
+          <p:nvPr>
+            <p:ph type="sldImg" idx="2"/>
+          </p:nvPr>
+        </p:nvSpPr>
+        <p:spPr/>
+      </p:sp>
+      <p:sp>
+        <p:nvSpPr>
+          <p:cNvPr id="3" name="Notes Placeholder 2"/>
+          <p:cNvSpPr>
+            <a:spLocks noGrp="1"/>
+          </p:cNvSpPr>
+          <p:nvPr>
+            <p:ph type="body" idx="3" sz="quarter"/>
+          </p:nvPr>
+        </p:nvSpPr>
+        <p:spPr/>
+        <p:txBody>
+          <a:bodyPr/>
+          <a:lstStyle/>
+          <a:p>
+            <a:r>
               <a:t>"Commando: Winning the Green Beret" by Hugh McManners vividly captures the journey of young recruits and seasoned volunteers through one of the most demanding military courses in the world. Its clear narrative, authentic dialogue and rich illustrations make the realities of commando training accessible to all readers. The book offers valuable lessons in resilience, discipline, leadership and integrity, and is highly recommended to all officers, particularly those engaged in training and the selection of soldiers for specialist units.</a:t>
             </a:r>
           </a:p>
@@ -1177,7 +1249,7 @@
           <a:lstStyle/>
           <a:p>
             <a:r>
-              <a:t>His blend of combat experience, insider knowledge of the Commando Brigade and journalistic skill makes him exceptionally qualified to write on the making of a commando. Falklands Commando was one of the first eye-witness accounts of combat in the Falklands War.</a:t>
+              <a:t>Photographs of the author, Hugh McManners: former Royal Artillery officer, Falklands veteran, journalist, television producer and author of some fifteen books.</a:t>
             </a:r>
           </a:p>
         </p:txBody>
@@ -1247,7 +1319,7 @@
           <a:lstStyle/>
           <a:p>
             <a:r>
-              <a:t>The hardcover features a striking dust jacket with a colour photograph of two mud-soaked recruits wading through water, the title in bold red, and a banner announcing that it accompanies the television series. The back cover carries a silhouette of commandos at sunset with the tagline: The most feared amphibious infantry in the world.</a:t>
+              <a:t>His blend of combat experience, insider knowledge of the Commando Brigade and journalistic skill makes him exceptionally qualified to write on the making of a commando. Falklands Commando was one of the first eye-witness accounts of combat in the Falklands War.</a:t>
             </a:r>
           </a:p>
         </p:txBody>
@@ -1317,7 +1389,7 @@
           <a:lstStyle/>
           <a:p>
             <a:r>
-              <a:t>The book contains an Introduction, seven chapters and an Epilogue, with an index. It is illustrated with black-and-white photographs taken during filming, an organisation chart of Commando Forces, a diagram of the endurance course and captioned group photographs. A Penguin paperback followed in 1995 and a revised Kindle edition in 2014.</a:t>
+              <a:t>The hardcover features a striking dust jacket with a colour photograph of two mud-soaked recruits wading through water, the title in bold red, and a banner announcing that it accompanies the television series. The back cover carries a silhouette of commandos at sunset with the tagline: The most feared amphibious infantry in the world.</a:t>
             </a:r>
           </a:p>
         </p:txBody>
@@ -1387,7 +1459,7 @@
           <a:lstStyle/>
           <a:p>
             <a:r>
-              <a:t>Introduction: history of the Commandos and the four Commando Tests; the essence of the tests is mental. Chapter 1: All Arms Course 4/92 - dunker trainer, cliff-climbing and the death dive; only 15 of 34 remain. Chapter 2: 638 Troop learn amphibious raiding at Poole and raid the Portland breakwater fort. Chapter 3: ambushed in their lorries, then their own dawn ambush; lessons in alertness and integrity. Chapter 4: advance to contact and night yomps on Dartmoor in relentless rain, ending with a dawn assault on a Napoleonic fort.</a:t>
+              <a:t>The book contains an Introduction, seven chapters and an Epilogue, with an index. It is illustrated with black-and-white photographs taken during filming, an organisation chart of Commando Forces, a diagram of the endurance course and captioned group photographs. A Penguin paperback followed in 1995 and a revised Kindle edition in 2014.</a:t>
             </a:r>
           </a:p>
         </p:txBody>
@@ -1457,7 +1529,7 @@
           <a:lstStyle/>
           <a:p>
             <a:r>
-              <a:t>Chapter 5: the training team judge each recruit by asking, "Would I be prepared to go to war with this man?"; Recruit Jaftha battles his fear of the Tarzan course chasm. Chapter 6: the endurance course, 9-mile speed march, Tarzan assault course and 30-mile march. Chapter 7: Recruit Spink wins the King’s Badge; the All Arms volunteers receive their Green Berets and the King’s Squad pass out before the First Sea Lord. Epilogue: the new commandos in Norway, Belize and Bosnia; Jaftha finally earns his Green Beret in February 1993.</a:t>
+              <a:t>Introduction: history of the Commandos and the four Commando Tests; the essence of the tests is mental. Chapter 1: All Arms Course 4/92 - dunker trainer, cliff-climbing and the death dive; only 15 of 34 remain. Chapter 2: 638 Troop learn amphibious raiding at Poole and raid the Portland breakwater fort. Chapter 3: ambushed in their lorries, then their own dawn ambush; lessons in alertness and integrity. Chapter 4: advance to contact and night yomps on Dartmoor in relentless rain, ending with a dawn assault on a Napoleonic fort.</a:t>
             </a:r>
           </a:p>
         </p:txBody>
@@ -1527,7 +1599,7 @@
           <a:lstStyle/>
           <a:p>
             <a:r>
-              <a:t>Significance: one of the most authoritative insider accounts of commando selection; shows how a respected institution turns ordinary young men into elite amphibious soldiers. Materials: entirely original, drawn from first-hand observation and the recorded words of recruits and instructors; opens doors normally closed to outsiders. Facts: test standards, numbers and dates recorded with precision; the Commandant and training teams read the chapters before publication. Clarity: logical sequence building to the Commando Tests; terms explained as they arise; organisation chart, endurance course diagram and captioned photographs. Readability: present-tense, documentary immediacy; vivid scenes and lively dialogue make it a page-turner. Mental stimulation: real dilemmas of selection, standards and integrity invite the reader to ask what he would have done. Broad-mindedness: every voice is heard, from recruit to Commandant; failures are treated with dignity. Inspiration: Jaftha’s perseverance, and leaders such as Colonel Taffinder, Major Lear and Captain Williams who take hard decisions with fairness.</a:t>
+              <a:t>Chapter 5: the training team judge each recruit by asking, "Would I be prepared to go to war with this man?"; Recruit Jaftha battles his fear of the Tarzan course chasm. Chapter 6: the endurance course, 9-mile speed march, Tarzan assault course and 30-mile march. Chapter 7: Recruit Spink wins the King’s Badge; the All Arms volunteers receive their Green Berets and the King’s Squad pass out before the First Sea Lord. Epilogue: the new commandos in Norway, Belize and Bosnia; Jaftha finally earns his Green Beret in February 1993.</a:t>
             </a:r>
           </a:p>
         </p:txBody>
@@ -2642,14 +2714,14 @@
       <p:grpSpPr/>
       <p:sp>
         <p:nvSpPr>
-          <p:cNvPr id="2" name="Section"/>
+          <p:cNvPr id="2" name="Title"/>
           <p:cNvSpPr txBox="1"/>
           <p:nvPr/>
         </p:nvSpPr>
         <p:spPr>
           <a:xfrm>
-            <a:off x="914400" y="2651760"/>
-            <a:ext cx="10360152" cy="1463040"/>
+            <a:off x="1051560" y="457200"/>
+            <a:ext cx="10085832" cy="594360"/>
           </a:xfrm>
           <a:prstGeom prst="rect">
             <a:avLst/>
@@ -2664,14 +2736,111 @@
           <a:p>
             <a:pPr algn="ctr"/>
             <a:r>
-              <a:rPr sz="3200" b="0" u="none" i="0">
-                <a:solidFill>
-                  <a:schemeClr val="bg1"/>
-                </a:solidFill>
-                <a:latin typeface="Arial"/>
-                <a:cs typeface="Arial"/>
-              </a:rPr>
-              <a:t>OVERVIEW OF THE BOOK</a:t>
+              <a:rPr sz="2800" b="0" u="sng" i="0">
+                <a:solidFill>
+                  <a:schemeClr val="bg1"/>
+                </a:solidFill>
+                <a:latin typeface="Arial"/>
+                <a:cs typeface="Arial"/>
+              </a:rPr>
+              <a:t>BIOGRAPHY OF HUGH McMANNERS (CONT)</a:t>
+            </a:r>
+          </a:p>
+        </p:txBody>
+      </p:sp>
+      <p:pic>
+        <p:nvPicPr>
+          <p:cNvPr id="3" name="Author photo 1" descr="u4.jpg"/>
+          <p:cNvPicPr>
+            <a:picLocks noChangeAspect="1"/>
+          </p:cNvPicPr>
+          <p:nvPr/>
+        </p:nvPicPr>
+        <p:blipFill>
+          <a:blip r:embed="rId2"/>
+          <a:stretch>
+            <a:fillRect/>
+          </a:stretch>
+        </p:blipFill>
+        <p:spPr>
+          <a:xfrm>
+            <a:off x="2011680" y="1325880"/>
+            <a:ext cx="3731998" cy="3749039"/>
+          </a:xfrm>
+          <a:prstGeom prst="rect">
+            <a:avLst/>
+          </a:prstGeom>
+        </p:spPr>
+      </p:pic>
+      <p:pic>
+        <p:nvPicPr>
+          <p:cNvPr id="4" name="Author photo 2" descr="u5.jpg"/>
+          <p:cNvPicPr>
+            <a:picLocks noChangeAspect="1"/>
+          </p:cNvPicPr>
+          <p:nvPr/>
+        </p:nvPicPr>
+        <p:blipFill>
+          <a:blip r:embed="rId3"/>
+          <a:stretch>
+            <a:fillRect/>
+          </a:stretch>
+        </p:blipFill>
+        <p:spPr>
+          <a:xfrm>
+            <a:off x="6309359" y="1325880"/>
+            <a:ext cx="3749039" cy="3749039"/>
+          </a:xfrm>
+          <a:prstGeom prst="rect">
+            <a:avLst/>
+          </a:prstGeom>
+        </p:spPr>
+      </p:pic>
+      <p:sp>
+        <p:nvSpPr>
+          <p:cNvPr id="5" name="Caption"/>
+          <p:cNvSpPr txBox="1"/>
+          <p:nvPr/>
+        </p:nvSpPr>
+        <p:spPr>
+          <a:xfrm>
+            <a:off x="1371600" y="5257800"/>
+            <a:ext cx="9445752" cy="640080"/>
+          </a:xfrm>
+          <a:prstGeom prst="rect">
+            <a:avLst/>
+          </a:prstGeom>
+          <a:noFill/>
+        </p:spPr>
+        <p:txBody>
+          <a:bodyPr wrap="square">
+            <a:spAutoFit/>
+          </a:bodyPr>
+          <a:lstStyle/>
+          <a:p>
+            <a:pPr algn="ctr"/>
+            <a:r>
+              <a:rPr sz="1600" b="0" u="none" i="0">
+                <a:solidFill>
+                  <a:schemeClr val="bg1"/>
+                </a:solidFill>
+                <a:latin typeface="Arial"/>
+                <a:cs typeface="Arial"/>
+              </a:rPr>
+              <a:t>Photos of Hugh McManners</a:t>
+            </a:r>
+          </a:p>
+          <a:p>
+            <a:pPr algn="ctr"/>
+            <a:r>
+              <a:rPr sz="1200" b="0" u="none" i="0">
+                <a:solidFill>
+                  <a:schemeClr val="bg1"/>
+                </a:solidFill>
+                <a:latin typeface="Arial"/>
+                <a:cs typeface="Arial"/>
+              </a:rPr>
+              <a:t>Source: https://www.google.com/search</a:t>
             </a:r>
           </a:p>
         </p:txBody>
@@ -2725,14 +2894,14 @@
                 <a:latin typeface="Arial"/>
                 <a:cs typeface="Arial"/>
               </a:rPr>
-              <a:t>OVERVIEW OF THE BOOK (CONT)</a:t>
+              <a:t>BIOGRAPHY OF HUGH McMANNERS (CONT)</a:t>
             </a:r>
           </a:p>
         </p:txBody>
       </p:sp>
       <p:pic>
         <p:nvPicPr>
-          <p:cNvPr id="3" name="Front cover" descr="cover-001.jpg"/>
+          <p:cNvPr id="3" name="Falklands Commando" descr="u3.jpg"/>
           <p:cNvPicPr>
             <a:picLocks noChangeAspect="1"/>
           </p:cNvPicPr>
@@ -2746,8 +2915,8 @@
         </p:blipFill>
         <p:spPr>
           <a:xfrm>
-            <a:off x="2331720" y="1188720"/>
-            <a:ext cx="2794515" cy="4343400"/>
+            <a:off x="777240" y="1280160"/>
+            <a:ext cx="2504750" cy="3886200"/>
           </a:xfrm>
           <a:prstGeom prst="rect">
             <a:avLst/>
@@ -2756,7 +2925,7 @@
       </p:pic>
       <p:pic>
         <p:nvPicPr>
-          <p:cNvPr id="4" name="Back cover" descr="back-200.jpg"/>
+          <p:cNvPr id="4" name="The Scars of War" descr="u2.jpg"/>
           <p:cNvPicPr>
             <a:picLocks noChangeAspect="1"/>
           </p:cNvPicPr>
@@ -2770,23 +2939,71 @@
         </p:blipFill>
         <p:spPr>
           <a:xfrm>
-            <a:off x="6263640" y="1188720"/>
-            <a:ext cx="2680461" cy="4343400"/>
+            <a:off x="3556309" y="1280160"/>
+            <a:ext cx="2532343" cy="3886200"/>
           </a:xfrm>
           <a:prstGeom prst="rect">
             <a:avLst/>
           </a:prstGeom>
         </p:spPr>
       </p:pic>
-      <p:sp>
-        <p:nvSpPr>
-          <p:cNvPr id="5" name="Caption"/>
+      <p:pic>
+        <p:nvPicPr>
+          <p:cNvPr id="5" name="Forgotten Voices of the Falklands" descr="u1.jpg"/>
+          <p:cNvPicPr>
+            <a:picLocks noChangeAspect="1"/>
+          </p:cNvPicPr>
+          <p:nvPr/>
+        </p:nvPicPr>
+        <p:blipFill>
+          <a:blip r:embed="rId4"/>
+          <a:stretch>
+            <a:fillRect/>
+          </a:stretch>
+        </p:blipFill>
+        <p:spPr>
+          <a:xfrm>
+            <a:off x="6362973" y="1280160"/>
+            <a:ext cx="2588209" cy="3886200"/>
+          </a:xfrm>
+          <a:prstGeom prst="rect">
+            <a:avLst/>
+          </a:prstGeom>
+        </p:spPr>
+      </p:pic>
+      <p:pic>
+        <p:nvPicPr>
+          <p:cNvPr id="6" name="Commando" descr="cover-001.jpg"/>
+          <p:cNvPicPr>
+            <a:picLocks noChangeAspect="1"/>
+          </p:cNvPicPr>
+          <p:nvPr/>
+        </p:nvPicPr>
+        <p:blipFill>
+          <a:blip r:embed="rId5"/>
+          <a:stretch>
+            <a:fillRect/>
+          </a:stretch>
+        </p:blipFill>
+        <p:spPr>
+          <a:xfrm>
+            <a:off x="9225502" y="1280160"/>
+            <a:ext cx="2500355" cy="3886200"/>
+          </a:xfrm>
+          <a:prstGeom prst="rect">
+            <a:avLst/>
+          </a:prstGeom>
+        </p:spPr>
+      </p:pic>
+      <p:sp>
+        <p:nvSpPr>
+          <p:cNvPr id="7" name="Caption"/>
           <p:cNvSpPr txBox="1"/>
           <p:nvPr/>
         </p:nvSpPr>
         <p:spPr>
           <a:xfrm>
-            <a:off x="1371600" y="5623560"/>
+            <a:off x="1371600" y="5349240"/>
             <a:ext cx="9445752" cy="640080"/>
           </a:xfrm>
           <a:prstGeom prst="rect">
@@ -2809,7 +3026,7 @@
                 <a:latin typeface="Arial"/>
                 <a:cs typeface="Arial"/>
               </a:rPr>
-              <a:t>Pictures showing the front and back covers of the book “Commando: Winning the Green Beret”</a:t>
+              <a:t>Some books authored by Hugh McManners</a:t>
             </a:r>
           </a:p>
           <a:p>
@@ -2822,7 +3039,7 @@
                 <a:latin typeface="Arial"/>
                 <a:cs typeface="Arial"/>
               </a:rPr>
-              <a:t>Source: McManners, H. (1994). Commando: Winning the Green Beret</a:t>
+              <a:t>Source: https://www.google.com/search</a:t>
             </a:r>
           </a:p>
         </p:txBody>
@@ -2847,14 +3064,14 @@
       <p:grpSpPr/>
       <p:sp>
         <p:nvSpPr>
-          <p:cNvPr id="2" name="Title"/>
+          <p:cNvPr id="2" name="Section"/>
           <p:cNvSpPr txBox="1"/>
           <p:nvPr/>
         </p:nvSpPr>
         <p:spPr>
           <a:xfrm>
-            <a:off x="1051560" y="457200"/>
-            <a:ext cx="10085832" cy="594360"/>
+            <a:off x="914400" y="2651760"/>
+            <a:ext cx="10360152" cy="1463040"/>
           </a:xfrm>
           <a:prstGeom prst="rect">
             <a:avLst/>
@@ -2869,236 +3086,18 @@
           <a:p>
             <a:pPr algn="ctr"/>
             <a:r>
-              <a:rPr sz="2800" b="0" u="sng" i="0">
-                <a:solidFill>
-                  <a:schemeClr val="bg1"/>
-                </a:solidFill>
-                <a:latin typeface="Arial"/>
-                <a:cs typeface="Arial"/>
-              </a:rPr>
-              <a:t>OVERVIEW OF THE BOOK (CONT)</a:t>
-            </a:r>
-          </a:p>
-        </p:txBody>
-      </p:sp>
-      <p:sp>
-        <p:nvSpPr>
-          <p:cNvPr id="3" name="Content"/>
-          <p:cNvSpPr txBox="1"/>
-          <p:nvPr/>
-        </p:nvSpPr>
-        <p:spPr>
-          <a:xfrm>
-            <a:off x="731520" y="1234440"/>
-            <a:ext cx="6766560" cy="5029200"/>
-          </a:xfrm>
-          <a:prstGeom prst="rect">
-            <a:avLst/>
-          </a:prstGeom>
-          <a:noFill/>
-        </p:spPr>
-        <p:txBody>
-          <a:bodyPr wrap="square">
-            <a:spAutoFit/>
-          </a:bodyPr>
-          <a:lstStyle/>
-          <a:p>
-            <a:pPr marL="457200" indent="-457200" algn="l">
-              <a:spcAft>
-                <a:spcPts val="600"/>
-              </a:spcAft>
-              <a:buFont typeface="Arial"/>
-              <a:buChar char="•"/>
-            </a:pPr>
-            <a:r>
-              <a:rPr sz="2400" b="0" u="none" i="0">
-                <a:solidFill>
-                  <a:schemeClr val="bg1"/>
-                </a:solidFill>
-                <a:latin typeface="Arial"/>
-                <a:cs typeface="Arial"/>
-              </a:rPr>
-              <a:t>Author: Hugh McManners</a:t>
-            </a:r>
-          </a:p>
-          <a:p>
-            <a:pPr marL="457200" indent="-457200" algn="l">
-              <a:spcAft>
-                <a:spcPts val="600"/>
-              </a:spcAft>
-              <a:buFont typeface="Arial"/>
-              <a:buChar char="•"/>
-            </a:pPr>
-            <a:r>
-              <a:rPr sz="2400" b="0" u="none" i="0">
-                <a:solidFill>
-                  <a:schemeClr val="bg1"/>
-                </a:solidFill>
-                <a:latin typeface="Arial"/>
-                <a:cs typeface="Arial"/>
-              </a:rPr>
-              <a:t>Year Published: 1994</a:t>
-            </a:r>
-          </a:p>
-          <a:p>
-            <a:pPr marL="457200" indent="-457200" algn="l">
-              <a:spcAft>
-                <a:spcPts val="600"/>
-              </a:spcAft>
-              <a:buFont typeface="Arial"/>
-              <a:buChar char="•"/>
-            </a:pPr>
-            <a:r>
-              <a:rPr sz="2400" b="0" u="none" i="0">
-                <a:solidFill>
-                  <a:schemeClr val="bg1"/>
-                </a:solidFill>
-                <a:latin typeface="Arial"/>
-                <a:cs typeface="Arial"/>
-              </a:rPr>
-              <a:t>Publisher: Network Books (BBC Books)</a:t>
-            </a:r>
-          </a:p>
-          <a:p>
-            <a:pPr marL="457200" indent="-457200" algn="l">
-              <a:spcAft>
-                <a:spcPts val="600"/>
-              </a:spcAft>
-              <a:buFont typeface="Arial"/>
-              <a:buChar char="•"/>
-            </a:pPr>
-            <a:r>
-              <a:rPr sz="2400" b="0" u="none" i="0">
-                <a:solidFill>
-                  <a:schemeClr val="bg1"/>
-                </a:solidFill>
-                <a:latin typeface="Arial"/>
-                <a:cs typeface="Arial"/>
-              </a:rPr>
-              <a:t>Place of Publishing: London, Great Britain</a:t>
-            </a:r>
-          </a:p>
-          <a:p>
-            <a:pPr marL="457200" indent="-457200" algn="l">
-              <a:spcAft>
-                <a:spcPts val="600"/>
-              </a:spcAft>
-              <a:buFont typeface="Arial"/>
-              <a:buChar char="•"/>
-            </a:pPr>
-            <a:r>
-              <a:rPr sz="2400" b="0" u="none" i="0">
-                <a:solidFill>
-                  <a:schemeClr val="bg1"/>
-                </a:solidFill>
-                <a:latin typeface="Arial"/>
-                <a:cs typeface="Arial"/>
-              </a:rPr>
-              <a:t>ISBN: 0-563-36981-7</a:t>
-            </a:r>
-          </a:p>
-          <a:p>
-            <a:pPr marL="457200" indent="-457200" algn="l">
-              <a:spcAft>
-                <a:spcPts val="600"/>
-              </a:spcAft>
-              <a:buFont typeface="Arial"/>
-              <a:buChar char="•"/>
-            </a:pPr>
-            <a:r>
-              <a:rPr sz="2400" b="0" u="none" i="0">
-                <a:solidFill>
-                  <a:schemeClr val="bg1"/>
-                </a:solidFill>
-                <a:latin typeface="Arial"/>
-                <a:cs typeface="Arial"/>
-              </a:rPr>
-              <a:t>Format: Hardcover</a:t>
-            </a:r>
-          </a:p>
-          <a:p>
-            <a:pPr marL="457200" indent="-457200" algn="l">
-              <a:spcAft>
-                <a:spcPts val="600"/>
-              </a:spcAft>
-              <a:buFont typeface="Arial"/>
-              <a:buChar char="•"/>
-            </a:pPr>
-            <a:r>
-              <a:rPr sz="2400" b="0" u="none" i="0">
-                <a:solidFill>
-                  <a:schemeClr val="bg1"/>
-                </a:solidFill>
-                <a:latin typeface="Arial"/>
-                <a:cs typeface="Arial"/>
-              </a:rPr>
-              <a:t>Number of pages: 192</a:t>
-            </a:r>
-          </a:p>
-          <a:p>
-            <a:pPr marL="457200" indent="-457200" algn="l">
-              <a:spcAft>
-                <a:spcPts val="600"/>
-              </a:spcAft>
-              <a:buFont typeface="Arial"/>
-              <a:buChar char="•"/>
-            </a:pPr>
-            <a:r>
-              <a:rPr sz="2400" b="0" u="none" i="0">
-                <a:solidFill>
-                  <a:schemeClr val="bg1"/>
-                </a:solidFill>
-                <a:latin typeface="Arial"/>
-                <a:cs typeface="Arial"/>
-              </a:rPr>
-              <a:t>Release Language: English</a:t>
-            </a:r>
-          </a:p>
-          <a:p>
-            <a:pPr marL="457200" indent="-457200" algn="l">
-              <a:spcAft>
-                <a:spcPts val="600"/>
-              </a:spcAft>
-              <a:buFont typeface="Arial"/>
-              <a:buChar char="•"/>
-            </a:pPr>
-            <a:r>
-              <a:rPr sz="2400" b="0" u="none" i="0">
-                <a:solidFill>
-                  <a:schemeClr val="bg1"/>
-                </a:solidFill>
-                <a:latin typeface="Arial"/>
-                <a:cs typeface="Arial"/>
-              </a:rPr>
-              <a:t>Price: from £2.75 (Amazon, used)</a:t>
-            </a:r>
-          </a:p>
-        </p:txBody>
-      </p:sp>
-      <p:pic>
-        <p:nvPicPr>
-          <p:cNvPr id="4" name="Front cover" descr="cover-001.jpg"/>
-          <p:cNvPicPr>
-            <a:picLocks noChangeAspect="1"/>
-          </p:cNvPicPr>
-          <p:nvPr/>
-        </p:nvPicPr>
-        <p:blipFill>
-          <a:blip r:embed="rId2"/>
-          <a:stretch>
-            <a:fillRect/>
-          </a:stretch>
-        </p:blipFill>
-        <p:spPr>
-          <a:xfrm>
-            <a:off x="8001000" y="1234440"/>
-            <a:ext cx="3176922" cy="4937760"/>
-          </a:xfrm>
-          <a:prstGeom prst="rect">
-            <a:avLst/>
-          </a:prstGeom>
-        </p:spPr>
-      </p:pic>
+              <a:rPr sz="3200" b="0" u="none" i="0">
+                <a:solidFill>
+                  <a:schemeClr val="bg1"/>
+                </a:solidFill>
+                <a:latin typeface="Arial"/>
+                <a:cs typeface="Arial"/>
+              </a:rPr>
+              <a:t>OVERVIEW OF THE BOOK</a:t>
+            </a:r>
+          </a:p>
+        </p:txBody>
+      </p:sp>
     </p:spTree>
   </p:cSld>
   <p:clrMapOvr>
@@ -3119,14 +3118,14 @@
       <p:grpSpPr/>
       <p:sp>
         <p:nvSpPr>
-          <p:cNvPr id="2" name="Section"/>
+          <p:cNvPr id="2" name="Title"/>
           <p:cNvSpPr txBox="1"/>
           <p:nvPr/>
         </p:nvSpPr>
         <p:spPr>
           <a:xfrm>
-            <a:off x="914400" y="2651760"/>
-            <a:ext cx="10360152" cy="1463040"/>
+            <a:off x="1051560" y="457200"/>
+            <a:ext cx="10085832" cy="594360"/>
           </a:xfrm>
           <a:prstGeom prst="rect">
             <a:avLst/>
@@ -3141,14 +3140,111 @@
           <a:p>
             <a:pPr algn="ctr"/>
             <a:r>
-              <a:rPr sz="3200" b="0" u="none" i="0">
-                <a:solidFill>
-                  <a:schemeClr val="bg1"/>
-                </a:solidFill>
-                <a:latin typeface="Arial"/>
-                <a:cs typeface="Arial"/>
-              </a:rPr>
-              <a:t>SUMMARY OF THE BOOK</a:t>
+              <a:rPr sz="2800" b="0" u="sng" i="0">
+                <a:solidFill>
+                  <a:schemeClr val="bg1"/>
+                </a:solidFill>
+                <a:latin typeface="Arial"/>
+                <a:cs typeface="Arial"/>
+              </a:rPr>
+              <a:t>OVERVIEW OF THE BOOK (CONT)</a:t>
+            </a:r>
+          </a:p>
+        </p:txBody>
+      </p:sp>
+      <p:pic>
+        <p:nvPicPr>
+          <p:cNvPr id="3" name="Front cover" descr="cover-001.jpg"/>
+          <p:cNvPicPr>
+            <a:picLocks noChangeAspect="1"/>
+          </p:cNvPicPr>
+          <p:nvPr/>
+        </p:nvPicPr>
+        <p:blipFill>
+          <a:blip r:embed="rId2"/>
+          <a:stretch>
+            <a:fillRect/>
+          </a:stretch>
+        </p:blipFill>
+        <p:spPr>
+          <a:xfrm>
+            <a:off x="2331720" y="1188720"/>
+            <a:ext cx="2794515" cy="4343400"/>
+          </a:xfrm>
+          <a:prstGeom prst="rect">
+            <a:avLst/>
+          </a:prstGeom>
+        </p:spPr>
+      </p:pic>
+      <p:pic>
+        <p:nvPicPr>
+          <p:cNvPr id="4" name="Back cover" descr="back-200.jpg"/>
+          <p:cNvPicPr>
+            <a:picLocks noChangeAspect="1"/>
+          </p:cNvPicPr>
+          <p:nvPr/>
+        </p:nvPicPr>
+        <p:blipFill>
+          <a:blip r:embed="rId3"/>
+          <a:stretch>
+            <a:fillRect/>
+          </a:stretch>
+        </p:blipFill>
+        <p:spPr>
+          <a:xfrm>
+            <a:off x="6263640" y="1188720"/>
+            <a:ext cx="2680461" cy="4343400"/>
+          </a:xfrm>
+          <a:prstGeom prst="rect">
+            <a:avLst/>
+          </a:prstGeom>
+        </p:spPr>
+      </p:pic>
+      <p:sp>
+        <p:nvSpPr>
+          <p:cNvPr id="5" name="Caption"/>
+          <p:cNvSpPr txBox="1"/>
+          <p:nvPr/>
+        </p:nvSpPr>
+        <p:spPr>
+          <a:xfrm>
+            <a:off x="1371600" y="5623560"/>
+            <a:ext cx="9445752" cy="640080"/>
+          </a:xfrm>
+          <a:prstGeom prst="rect">
+            <a:avLst/>
+          </a:prstGeom>
+          <a:noFill/>
+        </p:spPr>
+        <p:txBody>
+          <a:bodyPr wrap="square">
+            <a:spAutoFit/>
+          </a:bodyPr>
+          <a:lstStyle/>
+          <a:p>
+            <a:pPr algn="ctr"/>
+            <a:r>
+              <a:rPr sz="1600" b="0" u="none" i="0">
+                <a:solidFill>
+                  <a:schemeClr val="bg1"/>
+                </a:solidFill>
+                <a:latin typeface="Arial"/>
+                <a:cs typeface="Arial"/>
+              </a:rPr>
+              <a:t>Pictures showing the front and back covers of the book “Commando: Winning the Green Beret”</a:t>
+            </a:r>
+          </a:p>
+          <a:p>
+            <a:pPr algn="ctr"/>
+            <a:r>
+              <a:rPr sz="1200" b="0" u="none" i="0">
+                <a:solidFill>
+                  <a:schemeClr val="bg1"/>
+                </a:solidFill>
+                <a:latin typeface="Arial"/>
+                <a:cs typeface="Arial"/>
+              </a:rPr>
+              <a:t>Source: McManners, H. (1994). Commando: Winning the Green Beret</a:t>
             </a:r>
           </a:p>
         </p:txBody>
@@ -3202,7 +3298,7 @@
                 <a:latin typeface="Arial"/>
                 <a:cs typeface="Arial"/>
               </a:rPr>
-              <a:t>SUMMARY OF THE BOOK (CONT)</a:t>
+              <a:t>OVERVIEW OF THE BOOK (CONT)</a:t>
             </a:r>
           </a:p>
         </p:txBody>
@@ -3215,8 +3311,8 @@
         </p:nvSpPr>
         <p:spPr>
           <a:xfrm>
-            <a:off x="822960" y="1371600"/>
-            <a:ext cx="10515600" cy="5029200"/>
+            <a:off x="731520" y="1234440"/>
+            <a:ext cx="6766560" cy="5029200"/>
           </a:xfrm>
           <a:prstGeom prst="rect">
             <a:avLst/>
@@ -3229,97 +3325,202 @@
           </a:bodyPr>
           <a:lstStyle/>
           <a:p>
-            <a:pPr algn="l">
+            <a:pPr marL="457200" indent="-457200" algn="l">
               <a:spcAft>
-                <a:spcPts val="1600"/>
+                <a:spcPts val="600"/>
               </a:spcAft>
-              <a:buNone/>
+              <a:buFont typeface="Arial"/>
+              <a:buChar char="•"/>
             </a:pPr>
             <a:r>
-              <a:rPr sz="2800" b="0" u="none" i="0">
-                <a:solidFill>
-                  <a:schemeClr val="bg1"/>
-                </a:solidFill>
-                <a:latin typeface="Arial"/>
-                <a:cs typeface="Arial"/>
-              </a:rPr>
-              <a:t>Introduction</a:t>
-            </a:r>
-          </a:p>
-          <a:p>
-            <a:pPr algn="l">
+              <a:rPr sz="2400" b="0" u="none" i="0">
+                <a:solidFill>
+                  <a:schemeClr val="bg1"/>
+                </a:solidFill>
+                <a:latin typeface="Arial"/>
+                <a:cs typeface="Arial"/>
+              </a:rPr>
+              <a:t>Author: Hugh McManners</a:t>
+            </a:r>
+          </a:p>
+          <a:p>
+            <a:pPr marL="457200" indent="-457200" algn="l">
               <a:spcAft>
-                <a:spcPts val="1600"/>
+                <a:spcPts val="600"/>
               </a:spcAft>
-              <a:buNone/>
+              <a:buFont typeface="Arial"/>
+              <a:buChar char="•"/>
             </a:pPr>
             <a:r>
-              <a:rPr sz="2800" b="0" u="none" i="0">
-                <a:solidFill>
-                  <a:schemeClr val="bg1"/>
-                </a:solidFill>
-                <a:latin typeface="Arial"/>
-                <a:cs typeface="Arial"/>
-              </a:rPr>
-              <a:t>Chapter 1: All Arms, Volunteer Commandos</a:t>
-            </a:r>
-          </a:p>
-          <a:p>
-            <a:pPr algn="l">
+              <a:rPr sz="2400" b="0" u="none" i="0">
+                <a:solidFill>
+                  <a:schemeClr val="bg1"/>
+                </a:solidFill>
+                <a:latin typeface="Arial"/>
+                <a:cs typeface="Arial"/>
+              </a:rPr>
+              <a:t>Year Published: 1994</a:t>
+            </a:r>
+          </a:p>
+          <a:p>
+            <a:pPr marL="457200" indent="-457200" algn="l">
               <a:spcAft>
-                <a:spcPts val="1600"/>
+                <a:spcPts val="600"/>
               </a:spcAft>
-              <a:buNone/>
+              <a:buFont typeface="Arial"/>
+              <a:buChar char="•"/>
             </a:pPr>
             <a:r>
-              <a:rPr sz="2800" b="0" u="none" i="0">
-                <a:solidFill>
-                  <a:schemeClr val="bg1"/>
-                </a:solidFill>
-                <a:latin typeface="Arial"/>
-                <a:cs typeface="Arial"/>
-              </a:rPr>
-              <a:t>Chapter 2: Dawn Assault</a:t>
-            </a:r>
-          </a:p>
-          <a:p>
-            <a:pPr algn="l">
+              <a:rPr sz="2400" b="0" u="none" i="0">
+                <a:solidFill>
+                  <a:schemeClr val="bg1"/>
+                </a:solidFill>
+                <a:latin typeface="Arial"/>
+                <a:cs typeface="Arial"/>
+              </a:rPr>
+              <a:t>Publisher: Network Books (BBC Books)</a:t>
+            </a:r>
+          </a:p>
+          <a:p>
+            <a:pPr marL="457200" indent="-457200" algn="l">
               <a:spcAft>
-                <a:spcPts val="1600"/>
+                <a:spcPts val="600"/>
               </a:spcAft>
-              <a:buNone/>
+              <a:buFont typeface="Arial"/>
+              <a:buChar char="•"/>
             </a:pPr>
             <a:r>
-              <a:rPr sz="2800" b="0" u="none" i="0">
-                <a:solidFill>
-                  <a:schemeClr val="bg1"/>
-                </a:solidFill>
-                <a:latin typeface="Arial"/>
-                <a:cs typeface="Arial"/>
-              </a:rPr>
-              <a:t>Chapter 3: Ambush</a:t>
-            </a:r>
-          </a:p>
-          <a:p>
-            <a:pPr algn="l">
+              <a:rPr sz="2400" b="0" u="none" i="0">
+                <a:solidFill>
+                  <a:schemeClr val="bg1"/>
+                </a:solidFill>
+                <a:latin typeface="Arial"/>
+                <a:cs typeface="Arial"/>
+              </a:rPr>
+              <a:t>Place of Publishing: London, Great Britain</a:t>
+            </a:r>
+          </a:p>
+          <a:p>
+            <a:pPr marL="457200" indent="-457200" algn="l">
               <a:spcAft>
-                <a:spcPts val="1600"/>
+                <a:spcPts val="600"/>
               </a:spcAft>
-              <a:buNone/>
+              <a:buFont typeface="Arial"/>
+              <a:buChar char="•"/>
             </a:pPr>
             <a:r>
-              <a:rPr sz="2800" b="0" u="none" i="0">
-                <a:solidFill>
-                  <a:schemeClr val="bg1"/>
-                </a:solidFill>
-                <a:latin typeface="Arial"/>
-                <a:cs typeface="Arial"/>
-              </a:rPr>
-              <a:t>Chapter 4: 638 Troop – Dartmoor</a:t>
-            </a:r>
-          </a:p>
-        </p:txBody>
-      </p:sp>
+              <a:rPr sz="2400" b="0" u="none" i="0">
+                <a:solidFill>
+                  <a:schemeClr val="bg1"/>
+                </a:solidFill>
+                <a:latin typeface="Arial"/>
+                <a:cs typeface="Arial"/>
+              </a:rPr>
+              <a:t>ISBN: 0-563-36981-7</a:t>
+            </a:r>
+          </a:p>
+          <a:p>
+            <a:pPr marL="457200" indent="-457200" algn="l">
+              <a:spcAft>
+                <a:spcPts val="600"/>
+              </a:spcAft>
+              <a:buFont typeface="Arial"/>
+              <a:buChar char="•"/>
+            </a:pPr>
+            <a:r>
+              <a:rPr sz="2400" b="0" u="none" i="0">
+                <a:solidFill>
+                  <a:schemeClr val="bg1"/>
+                </a:solidFill>
+                <a:latin typeface="Arial"/>
+                <a:cs typeface="Arial"/>
+              </a:rPr>
+              <a:t>Format: Hardcover</a:t>
+            </a:r>
+          </a:p>
+          <a:p>
+            <a:pPr marL="457200" indent="-457200" algn="l">
+              <a:spcAft>
+                <a:spcPts val="600"/>
+              </a:spcAft>
+              <a:buFont typeface="Arial"/>
+              <a:buChar char="•"/>
+            </a:pPr>
+            <a:r>
+              <a:rPr sz="2400" b="0" u="none" i="0">
+                <a:solidFill>
+                  <a:schemeClr val="bg1"/>
+                </a:solidFill>
+                <a:latin typeface="Arial"/>
+                <a:cs typeface="Arial"/>
+              </a:rPr>
+              <a:t>Number of pages: 192</a:t>
+            </a:r>
+          </a:p>
+          <a:p>
+            <a:pPr marL="457200" indent="-457200" algn="l">
+              <a:spcAft>
+                <a:spcPts val="600"/>
+              </a:spcAft>
+              <a:buFont typeface="Arial"/>
+              <a:buChar char="•"/>
+            </a:pPr>
+            <a:r>
+              <a:rPr sz="2400" b="0" u="none" i="0">
+                <a:solidFill>
+                  <a:schemeClr val="bg1"/>
+                </a:solidFill>
+                <a:latin typeface="Arial"/>
+                <a:cs typeface="Arial"/>
+              </a:rPr>
+              <a:t>Release Language: English</a:t>
+            </a:r>
+          </a:p>
+          <a:p>
+            <a:pPr marL="457200" indent="-457200" algn="l">
+              <a:spcAft>
+                <a:spcPts val="600"/>
+              </a:spcAft>
+              <a:buFont typeface="Arial"/>
+              <a:buChar char="•"/>
+            </a:pPr>
+            <a:r>
+              <a:rPr sz="2400" b="0" u="none" i="0">
+                <a:solidFill>
+                  <a:schemeClr val="bg1"/>
+                </a:solidFill>
+                <a:latin typeface="Arial"/>
+                <a:cs typeface="Arial"/>
+              </a:rPr>
+              <a:t>Price: from £2.75 (Amazon, used)</a:t>
+            </a:r>
+          </a:p>
+        </p:txBody>
+      </p:sp>
+      <p:pic>
+        <p:nvPicPr>
+          <p:cNvPr id="4" name="Front cover" descr="cover-001.jpg"/>
+          <p:cNvPicPr>
+            <a:picLocks noChangeAspect="1"/>
+          </p:cNvPicPr>
+          <p:nvPr/>
+        </p:nvPicPr>
+        <p:blipFill>
+          <a:blip r:embed="rId2"/>
+          <a:stretch>
+            <a:fillRect/>
+          </a:stretch>
+        </p:blipFill>
+        <p:spPr>
+          <a:xfrm>
+            <a:off x="8001000" y="1234440"/>
+            <a:ext cx="3176922" cy="4937760"/>
+          </a:xfrm>
+          <a:prstGeom prst="rect">
+            <a:avLst/>
+          </a:prstGeom>
+        </p:spPr>
+      </p:pic>
     </p:spTree>
   </p:cSld>
   <p:clrMapOvr>
@@ -3340,14 +3541,14 @@
       <p:grpSpPr/>
       <p:sp>
         <p:nvSpPr>
-          <p:cNvPr id="2" name="Title"/>
+          <p:cNvPr id="2" name="Section"/>
           <p:cNvSpPr txBox="1"/>
           <p:nvPr/>
         </p:nvSpPr>
         <p:spPr>
           <a:xfrm>
-            <a:off x="1051560" y="457200"/>
-            <a:ext cx="10085832" cy="594360"/>
+            <a:off x="914400" y="2651760"/>
+            <a:ext cx="10360152" cy="1463040"/>
           </a:xfrm>
           <a:prstGeom prst="rect">
             <a:avLst/>
@@ -3362,109 +3563,14 @@
           <a:p>
             <a:pPr algn="ctr"/>
             <a:r>
-              <a:rPr sz="2800" b="0" u="sng" i="0">
-                <a:solidFill>
-                  <a:schemeClr val="bg1"/>
-                </a:solidFill>
-                <a:latin typeface="Arial"/>
-                <a:cs typeface="Arial"/>
-              </a:rPr>
-              <a:t>SUMMARY OF THE BOOK (CONT)</a:t>
-            </a:r>
-          </a:p>
-        </p:txBody>
-      </p:sp>
-      <p:sp>
-        <p:nvSpPr>
-          <p:cNvPr id="3" name="Content"/>
-          <p:cNvSpPr txBox="1"/>
-          <p:nvPr/>
-        </p:nvSpPr>
-        <p:spPr>
-          <a:xfrm>
-            <a:off x="822960" y="1371600"/>
-            <a:ext cx="10515600" cy="5029200"/>
-          </a:xfrm>
-          <a:prstGeom prst="rect">
-            <a:avLst/>
-          </a:prstGeom>
-          <a:noFill/>
-        </p:spPr>
-        <p:txBody>
-          <a:bodyPr wrap="square">
-            <a:spAutoFit/>
-          </a:bodyPr>
-          <a:lstStyle/>
-          <a:p>
-            <a:pPr algn="l">
-              <a:spcAft>
-                <a:spcPts val="1600"/>
-              </a:spcAft>
-              <a:buNone/>
-            </a:pPr>
-            <a:r>
-              <a:rPr sz="2800" b="0" u="none" i="0">
-                <a:solidFill>
-                  <a:schemeClr val="bg1"/>
-                </a:solidFill>
-                <a:latin typeface="Arial"/>
-                <a:cs typeface="Arial"/>
-              </a:rPr>
-              <a:t>Chapter 5: The Reckoning</a:t>
-            </a:r>
-          </a:p>
-          <a:p>
-            <a:pPr algn="l">
-              <a:spcAft>
-                <a:spcPts val="1600"/>
-              </a:spcAft>
-              <a:buNone/>
-            </a:pPr>
-            <a:r>
-              <a:rPr sz="2800" b="0" u="none" i="0">
-                <a:solidFill>
-                  <a:schemeClr val="bg1"/>
-                </a:solidFill>
-                <a:latin typeface="Arial"/>
-                <a:cs typeface="Arial"/>
-              </a:rPr>
-              <a:t>Chapter 6: 638 Troop – Commando Tests</a:t>
-            </a:r>
-          </a:p>
-          <a:p>
-            <a:pPr algn="l">
-              <a:spcAft>
-                <a:spcPts val="1600"/>
-              </a:spcAft>
-              <a:buNone/>
-            </a:pPr>
-            <a:r>
-              <a:rPr sz="2800" b="0" u="none" i="0">
-                <a:solidFill>
-                  <a:schemeClr val="bg1"/>
-                </a:solidFill>
-                <a:latin typeface="Arial"/>
-                <a:cs typeface="Arial"/>
-              </a:rPr>
-              <a:t>Chapter 7: The End of the Road</a:t>
-            </a:r>
-          </a:p>
-          <a:p>
-            <a:pPr algn="l">
-              <a:spcAft>
-                <a:spcPts val="1600"/>
-              </a:spcAft>
-              <a:buNone/>
-            </a:pPr>
-            <a:r>
-              <a:rPr sz="2800" b="0" u="none" i="0">
-                <a:solidFill>
-                  <a:schemeClr val="bg1"/>
-                </a:solidFill>
-                <a:latin typeface="Arial"/>
-                <a:cs typeface="Arial"/>
-              </a:rPr>
-              <a:t>Epilogue</a:t>
+              <a:rPr sz="3200" b="0" u="none" i="0">
+                <a:solidFill>
+                  <a:schemeClr val="bg1"/>
+                </a:solidFill>
+                <a:latin typeface="Arial"/>
+                <a:cs typeface="Arial"/>
+              </a:rPr>
+              <a:t>SUMMARY OF THE BOOK</a:t>
             </a:r>
           </a:p>
         </p:txBody>
@@ -3523,112 +3629,16 @@
           </a:p>
         </p:txBody>
       </p:sp>
-      <p:pic>
-        <p:nvPicPr>
-          <p:cNvPr id="3" name="Raiders" descr="raiders.jpg"/>
-          <p:cNvPicPr>
-            <a:picLocks noChangeAspect="1"/>
-          </p:cNvPicPr>
-          <p:nvPr/>
-        </p:nvPicPr>
-        <p:blipFill>
-          <a:blip r:embed="rId2"/>
-          <a:stretch>
-            <a:fillRect/>
-          </a:stretch>
-        </p:blipFill>
-        <p:spPr>
-          <a:xfrm>
-            <a:off x="1966087" y="1143000"/>
-            <a:ext cx="2880106" cy="2103120"/>
-          </a:xfrm>
-          <a:prstGeom prst="rect">
-            <a:avLst/>
-          </a:prstGeom>
-        </p:spPr>
-      </p:pic>
-      <p:pic>
-        <p:nvPicPr>
-          <p:cNvPr id="4" name="Jaftha" descr="jaftha.jpg"/>
-          <p:cNvPicPr>
-            <a:picLocks noChangeAspect="1"/>
-          </p:cNvPicPr>
-          <p:nvPr/>
-        </p:nvPicPr>
-        <p:blipFill>
-          <a:blip r:embed="rId3"/>
-          <a:stretch>
-            <a:fillRect/>
-          </a:stretch>
-        </p:blipFill>
-        <p:spPr>
-          <a:xfrm>
-            <a:off x="7317643" y="1143000"/>
-            <a:ext cx="2875472" cy="2103119"/>
-          </a:xfrm>
-          <a:prstGeom prst="rect">
-            <a:avLst/>
-          </a:prstGeom>
-        </p:spPr>
-      </p:pic>
-      <p:pic>
-        <p:nvPicPr>
-          <p:cNvPr id="5" name="All Arms" descr="allarms.jpg"/>
-          <p:cNvPicPr>
-            <a:picLocks noChangeAspect="1"/>
-          </p:cNvPicPr>
-          <p:nvPr/>
-        </p:nvPicPr>
-        <p:blipFill>
-          <a:blip r:embed="rId4"/>
-          <a:stretch>
-            <a:fillRect/>
-          </a:stretch>
-        </p:blipFill>
-        <p:spPr>
-          <a:xfrm>
-            <a:off x="1808655" y="3429000"/>
-            <a:ext cx="3194969" cy="2103120"/>
-          </a:xfrm>
-          <a:prstGeom prst="rect">
-            <a:avLst/>
-          </a:prstGeom>
-        </p:spPr>
-      </p:pic>
-      <p:pic>
-        <p:nvPicPr>
-          <p:cNvPr id="6" name="Berets" descr="berets.jpg"/>
-          <p:cNvPicPr>
-            <a:picLocks noChangeAspect="1"/>
-          </p:cNvPicPr>
-          <p:nvPr/>
-        </p:nvPicPr>
-        <p:blipFill>
-          <a:blip r:embed="rId5"/>
-          <a:stretch>
-            <a:fillRect/>
-          </a:stretch>
-        </p:blipFill>
-        <p:spPr>
-          <a:xfrm>
-            <a:off x="6723339" y="3429000"/>
-            <a:ext cx="4064080" cy="2103120"/>
-          </a:xfrm>
-          <a:prstGeom prst="rect">
-            <a:avLst/>
-          </a:prstGeom>
-        </p:spPr>
-      </p:pic>
-      <p:sp>
-        <p:nvSpPr>
-          <p:cNvPr id="7" name="Caption"/>
+      <p:sp>
+        <p:nvSpPr>
+          <p:cNvPr id="3" name="Content"/>
           <p:cNvSpPr txBox="1"/>
           <p:nvPr/>
         </p:nvSpPr>
         <p:spPr>
           <a:xfrm>
-            <a:off x="411480" y="5669280"/>
-            <a:ext cx="11338560" cy="640080"/>
+            <a:off x="822960" y="1371600"/>
+            <a:ext cx="10515600" cy="5029200"/>
           </a:xfrm>
           <a:prstGeom prst="rect">
             <a:avLst/>
@@ -3641,29 +3651,93 @@
           </a:bodyPr>
           <a:lstStyle/>
           <a:p>
-            <a:pPr algn="ctr"/>
-            <a:r>
-              <a:rPr sz="1400" b="0" u="none" i="0">
-                <a:solidFill>
-                  <a:schemeClr val="bg1"/>
-                </a:solidFill>
-                <a:latin typeface="Arial"/>
-                <a:cs typeface="Arial"/>
-              </a:rPr>
-              <a:t>Scenes from the book: assault landing at Poole, Recruit Jaftha at the chasm, All Arms 4/92 on Dartmoor and new Green Berets</a:t>
-            </a:r>
-          </a:p>
-          <a:p>
-            <a:pPr algn="ctr"/>
-            <a:r>
-              <a:rPr sz="1200" b="0" u="none" i="0">
-                <a:solidFill>
-                  <a:schemeClr val="bg1"/>
-                </a:solidFill>
-                <a:latin typeface="Arial"/>
-                <a:cs typeface="Arial"/>
-              </a:rPr>
-              <a:t>Source: McManners, H. (1994). Commando: Winning the Green Beret</a:t>
+            <a:pPr algn="l">
+              <a:spcAft>
+                <a:spcPts val="1600"/>
+              </a:spcAft>
+              <a:buNone/>
+            </a:pPr>
+            <a:r>
+              <a:rPr sz="2800" b="0" u="none" i="0">
+                <a:solidFill>
+                  <a:schemeClr val="bg1"/>
+                </a:solidFill>
+                <a:latin typeface="Arial"/>
+                <a:cs typeface="Arial"/>
+              </a:rPr>
+              <a:t>Introduction</a:t>
+            </a:r>
+          </a:p>
+          <a:p>
+            <a:pPr algn="l">
+              <a:spcAft>
+                <a:spcPts val="1600"/>
+              </a:spcAft>
+              <a:buNone/>
+            </a:pPr>
+            <a:r>
+              <a:rPr sz="2800" b="0" u="none" i="0">
+                <a:solidFill>
+                  <a:schemeClr val="bg1"/>
+                </a:solidFill>
+                <a:latin typeface="Arial"/>
+                <a:cs typeface="Arial"/>
+              </a:rPr>
+              <a:t>Chapter 1: All Arms, Volunteer Commandos</a:t>
+            </a:r>
+          </a:p>
+          <a:p>
+            <a:pPr algn="l">
+              <a:spcAft>
+                <a:spcPts val="1600"/>
+              </a:spcAft>
+              <a:buNone/>
+            </a:pPr>
+            <a:r>
+              <a:rPr sz="2800" b="0" u="none" i="0">
+                <a:solidFill>
+                  <a:schemeClr val="bg1"/>
+                </a:solidFill>
+                <a:latin typeface="Arial"/>
+                <a:cs typeface="Arial"/>
+              </a:rPr>
+              <a:t>Chapter 2: Dawn Assault</a:t>
+            </a:r>
+          </a:p>
+          <a:p>
+            <a:pPr algn="l">
+              <a:spcAft>
+                <a:spcPts val="1600"/>
+              </a:spcAft>
+              <a:buNone/>
+            </a:pPr>
+            <a:r>
+              <a:rPr sz="2800" b="0" u="none" i="0">
+                <a:solidFill>
+                  <a:schemeClr val="bg1"/>
+                </a:solidFill>
+                <a:latin typeface="Arial"/>
+                <a:cs typeface="Arial"/>
+              </a:rPr>
+              <a:t>Chapter 3: Ambush</a:t>
+            </a:r>
+          </a:p>
+          <a:p>
+            <a:pPr algn="l">
+              <a:spcAft>
+                <a:spcPts val="1600"/>
+              </a:spcAft>
+              <a:buNone/>
+            </a:pPr>
+            <a:r>
+              <a:rPr sz="2800" b="0" u="none" i="0">
+                <a:solidFill>
+                  <a:schemeClr val="bg1"/>
+                </a:solidFill>
+                <a:latin typeface="Arial"/>
+                <a:cs typeface="Arial"/>
+              </a:rPr>
+              <a:t>Chapter 4: 638 Troop – Dartmoor</a:t>
             </a:r>
           </a:p>
         </p:txBody>
@@ -3688,14 +3762,14 @@
       <p:grpSpPr/>
       <p:sp>
         <p:nvSpPr>
-          <p:cNvPr id="2" name="Section"/>
+          <p:cNvPr id="2" name="Title"/>
           <p:cNvSpPr txBox="1"/>
           <p:nvPr/>
         </p:nvSpPr>
         <p:spPr>
           <a:xfrm>
-            <a:off x="914400" y="2651760"/>
-            <a:ext cx="10360152" cy="1463040"/>
+            <a:off x="1051560" y="457200"/>
+            <a:ext cx="10085832" cy="594360"/>
           </a:xfrm>
           <a:prstGeom prst="rect">
             <a:avLst/>
@@ -3710,14 +3784,109 @@
           <a:p>
             <a:pPr algn="ctr"/>
             <a:r>
-              <a:rPr sz="3200" b="0" u="none" i="0">
-                <a:solidFill>
-                  <a:schemeClr val="bg1"/>
-                </a:solidFill>
-                <a:latin typeface="Arial"/>
-                <a:cs typeface="Arial"/>
-              </a:rPr>
-              <a:t>EVALUATION OF THE BOOK</a:t>
+              <a:rPr sz="2800" b="0" u="sng" i="0">
+                <a:solidFill>
+                  <a:schemeClr val="bg1"/>
+                </a:solidFill>
+                <a:latin typeface="Arial"/>
+                <a:cs typeface="Arial"/>
+              </a:rPr>
+              <a:t>SUMMARY OF THE BOOK (CONT)</a:t>
+            </a:r>
+          </a:p>
+        </p:txBody>
+      </p:sp>
+      <p:sp>
+        <p:nvSpPr>
+          <p:cNvPr id="3" name="Content"/>
+          <p:cNvSpPr txBox="1"/>
+          <p:nvPr/>
+        </p:nvSpPr>
+        <p:spPr>
+          <a:xfrm>
+            <a:off x="822960" y="1371600"/>
+            <a:ext cx="10515600" cy="5029200"/>
+          </a:xfrm>
+          <a:prstGeom prst="rect">
+            <a:avLst/>
+          </a:prstGeom>
+          <a:noFill/>
+        </p:spPr>
+        <p:txBody>
+          <a:bodyPr wrap="square">
+            <a:spAutoFit/>
+          </a:bodyPr>
+          <a:lstStyle/>
+          <a:p>
+            <a:pPr algn="l">
+              <a:spcAft>
+                <a:spcPts val="1600"/>
+              </a:spcAft>
+              <a:buNone/>
+            </a:pPr>
+            <a:r>
+              <a:rPr sz="2800" b="0" u="none" i="0">
+                <a:solidFill>
+                  <a:schemeClr val="bg1"/>
+                </a:solidFill>
+                <a:latin typeface="Arial"/>
+                <a:cs typeface="Arial"/>
+              </a:rPr>
+              <a:t>Chapter 5: The Reckoning</a:t>
+            </a:r>
+          </a:p>
+          <a:p>
+            <a:pPr algn="l">
+              <a:spcAft>
+                <a:spcPts val="1600"/>
+              </a:spcAft>
+              <a:buNone/>
+            </a:pPr>
+            <a:r>
+              <a:rPr sz="2800" b="0" u="none" i="0">
+                <a:solidFill>
+                  <a:schemeClr val="bg1"/>
+                </a:solidFill>
+                <a:latin typeface="Arial"/>
+                <a:cs typeface="Arial"/>
+              </a:rPr>
+              <a:t>Chapter 6: 638 Troop – Commando Tests</a:t>
+            </a:r>
+          </a:p>
+          <a:p>
+            <a:pPr algn="l">
+              <a:spcAft>
+                <a:spcPts val="1600"/>
+              </a:spcAft>
+              <a:buNone/>
+            </a:pPr>
+            <a:r>
+              <a:rPr sz="2800" b="0" u="none" i="0">
+                <a:solidFill>
+                  <a:schemeClr val="bg1"/>
+                </a:solidFill>
+                <a:latin typeface="Arial"/>
+                <a:cs typeface="Arial"/>
+              </a:rPr>
+              <a:t>Chapter 7: The End of the Road</a:t>
+            </a:r>
+          </a:p>
+          <a:p>
+            <a:pPr algn="l">
+              <a:spcAft>
+                <a:spcPts val="1600"/>
+              </a:spcAft>
+              <a:buNone/>
+            </a:pPr>
+            <a:r>
+              <a:rPr sz="2800" b="0" u="none" i="0">
+                <a:solidFill>
+                  <a:schemeClr val="bg1"/>
+                </a:solidFill>
+                <a:latin typeface="Arial"/>
+                <a:cs typeface="Arial"/>
+              </a:rPr>
+              <a:t>Epilogue</a:t>
             </a:r>
           </a:p>
         </p:txBody>
@@ -3771,21 +3940,117 @@
                 <a:latin typeface="Arial"/>
                 <a:cs typeface="Arial"/>
               </a:rPr>
-              <a:t>EVALUATION OF THE BOOK (CONT)</a:t>
-            </a:r>
-          </a:p>
-        </p:txBody>
-      </p:sp>
-      <p:sp>
-        <p:nvSpPr>
-          <p:cNvPr id="3" name="Content"/>
+              <a:t>SUMMARY OF THE BOOK (CONT)</a:t>
+            </a:r>
+          </a:p>
+        </p:txBody>
+      </p:sp>
+      <p:pic>
+        <p:nvPicPr>
+          <p:cNvPr id="3" name="Raiders" descr="raiders.jpg"/>
+          <p:cNvPicPr>
+            <a:picLocks noChangeAspect="1"/>
+          </p:cNvPicPr>
+          <p:nvPr/>
+        </p:nvPicPr>
+        <p:blipFill>
+          <a:blip r:embed="rId2"/>
+          <a:stretch>
+            <a:fillRect/>
+          </a:stretch>
+        </p:blipFill>
+        <p:spPr>
+          <a:xfrm>
+            <a:off x="1966087" y="1143000"/>
+            <a:ext cx="2880106" cy="2103120"/>
+          </a:xfrm>
+          <a:prstGeom prst="rect">
+            <a:avLst/>
+          </a:prstGeom>
+        </p:spPr>
+      </p:pic>
+      <p:pic>
+        <p:nvPicPr>
+          <p:cNvPr id="4" name="Jaftha" descr="jaftha.jpg"/>
+          <p:cNvPicPr>
+            <a:picLocks noChangeAspect="1"/>
+          </p:cNvPicPr>
+          <p:nvPr/>
+        </p:nvPicPr>
+        <p:blipFill>
+          <a:blip r:embed="rId3"/>
+          <a:stretch>
+            <a:fillRect/>
+          </a:stretch>
+        </p:blipFill>
+        <p:spPr>
+          <a:xfrm>
+            <a:off x="7317643" y="1143000"/>
+            <a:ext cx="2875472" cy="2103119"/>
+          </a:xfrm>
+          <a:prstGeom prst="rect">
+            <a:avLst/>
+          </a:prstGeom>
+        </p:spPr>
+      </p:pic>
+      <p:pic>
+        <p:nvPicPr>
+          <p:cNvPr id="5" name="All Arms" descr="allarms.jpg"/>
+          <p:cNvPicPr>
+            <a:picLocks noChangeAspect="1"/>
+          </p:cNvPicPr>
+          <p:nvPr/>
+        </p:nvPicPr>
+        <p:blipFill>
+          <a:blip r:embed="rId4"/>
+          <a:stretch>
+            <a:fillRect/>
+          </a:stretch>
+        </p:blipFill>
+        <p:spPr>
+          <a:xfrm>
+            <a:off x="1808655" y="3429000"/>
+            <a:ext cx="3194969" cy="2103120"/>
+          </a:xfrm>
+          <a:prstGeom prst="rect">
+            <a:avLst/>
+          </a:prstGeom>
+        </p:spPr>
+      </p:pic>
+      <p:pic>
+        <p:nvPicPr>
+          <p:cNvPr id="6" name="Berets" descr="berets.jpg"/>
+          <p:cNvPicPr>
+            <a:picLocks noChangeAspect="1"/>
+          </p:cNvPicPr>
+          <p:nvPr/>
+        </p:nvPicPr>
+        <p:blipFill>
+          <a:blip r:embed="rId5"/>
+          <a:stretch>
+            <a:fillRect/>
+          </a:stretch>
+        </p:blipFill>
+        <p:spPr>
+          <a:xfrm>
+            <a:off x="6723339" y="3429000"/>
+            <a:ext cx="4064080" cy="2103120"/>
+          </a:xfrm>
+          <a:prstGeom prst="rect">
+            <a:avLst/>
+          </a:prstGeom>
+        </p:spPr>
+      </p:pic>
+      <p:sp>
+        <p:nvSpPr>
+          <p:cNvPr id="7" name="Caption"/>
           <p:cNvSpPr txBox="1"/>
           <p:nvPr/>
         </p:nvSpPr>
         <p:spPr>
           <a:xfrm>
-            <a:off x="1097280" y="1188720"/>
-            <a:ext cx="9601200" cy="5029200"/>
+            <a:off x="411480" y="5669280"/>
+            <a:ext cx="11338560" cy="640080"/>
           </a:xfrm>
           <a:prstGeom prst="rect">
             <a:avLst/>
@@ -3798,155 +4063,29 @@
           </a:bodyPr>
           <a:lstStyle/>
           <a:p>
-            <a:pPr marL="571500" indent="-571500" algn="l">
-              <a:spcAft>
-                <a:spcPts val="600"/>
-              </a:spcAft>
-              <a:buFont typeface="Arial"/>
-              <a:buAutoNum type="arabicPeriod"/>
-            </a:pPr>
-            <a:r>
-              <a:rPr sz="2600" b="0" u="none" i="0">
-                <a:solidFill>
-                  <a:schemeClr val="bg1"/>
-                </a:solidFill>
-                <a:latin typeface="Arial"/>
-                <a:cs typeface="Arial"/>
-              </a:rPr>
-              <a:t>Significance of the Book.</a:t>
-            </a:r>
-          </a:p>
-          <a:p>
-            <a:pPr marL="571500" indent="-571500" algn="l">
-              <a:spcAft>
-                <a:spcPts val="600"/>
-              </a:spcAft>
-              <a:buFont typeface="Arial"/>
-              <a:buAutoNum type="arabicPeriod"/>
-            </a:pPr>
-            <a:r>
-              <a:rPr sz="2600" b="0" u="none" i="0">
-                <a:solidFill>
-                  <a:schemeClr val="bg1"/>
-                </a:solidFill>
-                <a:latin typeface="Arial"/>
-                <a:cs typeface="Arial"/>
-              </a:rPr>
-              <a:t>Materials Used.</a:t>
-            </a:r>
-          </a:p>
-          <a:p>
-            <a:pPr marL="571500" indent="-571500" algn="l">
-              <a:spcAft>
-                <a:spcPts val="600"/>
-              </a:spcAft>
-              <a:buFont typeface="Arial"/>
-              <a:buAutoNum type="arabicPeriod"/>
-            </a:pPr>
-            <a:r>
-              <a:rPr sz="2600" b="0" u="none" i="0">
-                <a:solidFill>
-                  <a:schemeClr val="bg1"/>
-                </a:solidFill>
-                <a:latin typeface="Arial"/>
-                <a:cs typeface="Arial"/>
-              </a:rPr>
-              <a:t>Facts Presented.</a:t>
-            </a:r>
-          </a:p>
-          <a:p>
-            <a:pPr marL="571500" indent="-571500" algn="l">
-              <a:spcAft>
-                <a:spcPts val="600"/>
-              </a:spcAft>
-              <a:buFont typeface="Arial"/>
-              <a:buAutoNum type="arabicPeriod"/>
-            </a:pPr>
-            <a:r>
-              <a:rPr sz="2600" b="0" u="none" i="0">
-                <a:solidFill>
-                  <a:schemeClr val="bg1"/>
-                </a:solidFill>
-                <a:latin typeface="Arial"/>
-                <a:cs typeface="Arial"/>
-              </a:rPr>
-              <a:t>Clarity.</a:t>
-            </a:r>
-          </a:p>
-          <a:p>
-            <a:pPr marL="571500" indent="-571500" algn="l">
-              <a:spcAft>
-                <a:spcPts val="600"/>
-              </a:spcAft>
-              <a:buFont typeface="Arial"/>
-              <a:buAutoNum type="arabicPeriod"/>
-            </a:pPr>
-            <a:r>
-              <a:rPr sz="2600" b="0" u="none" i="0">
-                <a:solidFill>
-                  <a:schemeClr val="bg1"/>
-                </a:solidFill>
-                <a:latin typeface="Arial"/>
-                <a:cs typeface="Arial"/>
-              </a:rPr>
-              <a:t>Readability.</a:t>
-            </a:r>
-          </a:p>
-          <a:p>
-            <a:pPr marL="571500" indent="-571500" algn="l">
-              <a:spcAft>
-                <a:spcPts val="600"/>
-              </a:spcAft>
-              <a:buFont typeface="Arial"/>
-              <a:buAutoNum type="arabicPeriod"/>
-            </a:pPr>
-            <a:r>
-              <a:rPr sz="2600" b="0" u="none" i="0">
-                <a:solidFill>
-                  <a:schemeClr val="bg1"/>
-                </a:solidFill>
-                <a:latin typeface="Arial"/>
-                <a:cs typeface="Arial"/>
-              </a:rPr>
-              <a:t>Mental Stimulation.</a:t>
-            </a:r>
-          </a:p>
-          <a:p>
-            <a:pPr marL="571500" indent="-571500" algn="l">
-              <a:spcAft>
-                <a:spcPts val="600"/>
-              </a:spcAft>
-              <a:buFont typeface="Arial"/>
-              <a:buAutoNum type="arabicPeriod"/>
-            </a:pPr>
-            <a:r>
-              <a:rPr sz="2600" b="0" u="none" i="0">
-                <a:solidFill>
-                  <a:schemeClr val="bg1"/>
-                </a:solidFill>
-                <a:latin typeface="Arial"/>
-                <a:cs typeface="Arial"/>
-              </a:rPr>
-              <a:t>Broad-mindedness.</a:t>
-            </a:r>
-          </a:p>
-          <a:p>
-            <a:pPr marL="571500" indent="-571500" algn="l">
-              <a:spcAft>
-                <a:spcPts val="600"/>
-              </a:spcAft>
-              <a:buFont typeface="Arial"/>
-              <a:buAutoNum type="arabicPeriod"/>
-            </a:pPr>
-            <a:r>
-              <a:rPr sz="2600" b="0" u="none" i="0">
-                <a:solidFill>
-                  <a:schemeClr val="bg1"/>
-                </a:solidFill>
-                <a:latin typeface="Arial"/>
-                <a:cs typeface="Arial"/>
-              </a:rPr>
-              <a:t>Inspiration.</a:t>
+            <a:pPr algn="ctr"/>
+            <a:r>
+              <a:rPr sz="1400" b="0" u="none" i="0">
+                <a:solidFill>
+                  <a:schemeClr val="bg1"/>
+                </a:solidFill>
+                <a:latin typeface="Arial"/>
+                <a:cs typeface="Arial"/>
+              </a:rPr>
+              <a:t>Scenes from the book: assault landing at Poole, Recruit Jaftha at the chasm, All Arms 4/92 on Dartmoor and new Green Berets</a:t>
+            </a:r>
+          </a:p>
+          <a:p>
+            <a:pPr algn="ctr"/>
+            <a:r>
+              <a:rPr sz="1200" b="0" u="none" i="0">
+                <a:solidFill>
+                  <a:schemeClr val="bg1"/>
+                </a:solidFill>
+                <a:latin typeface="Arial"/>
+                <a:cs typeface="Arial"/>
+              </a:rPr>
+              <a:t>Source: McManners, H. (1994). Commando: Winning the Green Beret</a:t>
             </a:r>
           </a:p>
         </p:txBody>
@@ -4000,7 +4139,7 @@
                 <a:latin typeface="Arial"/>
                 <a:cs typeface="Arial"/>
               </a:rPr>
-              <a:t>LESSONS LEARNT</a:t>
+              <a:t>EVALUATION OF THE BOOK</a:t>
             </a:r>
           </a:p>
         </p:txBody>
@@ -4108,7 +4247,7 @@
                 <a:latin typeface="Arial"/>
                 <a:cs typeface="Arial"/>
               </a:rPr>
-              <a:t>LESSONS LEARNT (CONT)</a:t>
+              <a:t>EVALUATION OF THE BOOK (CONT)</a:t>
             </a:r>
           </a:p>
         </p:txBody>
@@ -4121,8 +4260,8 @@
         </p:nvSpPr>
         <p:spPr>
           <a:xfrm>
-            <a:off x="548640" y="1234440"/>
-            <a:ext cx="11064240" cy="5029200"/>
+            <a:off x="1097280" y="1188720"/>
+            <a:ext cx="9601200" cy="5029200"/>
           </a:xfrm>
           <a:prstGeom prst="rect">
             <a:avLst/>
@@ -4135,60 +4274,155 @@
           </a:bodyPr>
           <a:lstStyle/>
           <a:p>
-            <a:pPr marL="457200" indent="-457200" algn="just">
+            <a:pPr marL="571500" indent="-571500" algn="l">
               <a:spcAft>
-                <a:spcPts val="1800"/>
+                <a:spcPts val="600"/>
               </a:spcAft>
               <a:buFont typeface="Arial"/>
-              <a:buChar char="•"/>
+              <a:buAutoNum type="arabicPeriod"/>
             </a:pPr>
             <a:r>
-              <a:rPr sz="2400" b="0" u="none" i="0">
-                <a:solidFill>
-                  <a:schemeClr val="bg1"/>
-                </a:solidFill>
-                <a:latin typeface="Arial"/>
-                <a:cs typeface="Arial"/>
-              </a:rPr>
-              <a:t>Demonstrates that mental resilience, not physical strength alone, decides success under cold, fatigue and stress.</a:t>
-            </a:r>
-          </a:p>
-          <a:p>
-            <a:pPr marL="457200" indent="-457200" algn="just">
+              <a:rPr sz="2600" b="0" u="none" i="0">
+                <a:solidFill>
+                  <a:schemeClr val="bg1"/>
+                </a:solidFill>
+                <a:latin typeface="Arial"/>
+                <a:cs typeface="Arial"/>
+              </a:rPr>
+              <a:t>Significance of the Book.</a:t>
+            </a:r>
+          </a:p>
+          <a:p>
+            <a:pPr marL="571500" indent="-571500" algn="l">
               <a:spcAft>
-                <a:spcPts val="1800"/>
+                <a:spcPts val="600"/>
               </a:spcAft>
               <a:buFont typeface="Arial"/>
-              <a:buChar char="•"/>
+              <a:buAutoNum type="arabicPeriod"/>
             </a:pPr>
             <a:r>
-              <a:rPr sz="2400" b="0" u="none" i="0">
-                <a:solidFill>
-                  <a:schemeClr val="bg1"/>
-                </a:solidFill>
-                <a:latin typeface="Arial"/>
-                <a:cs typeface="Arial"/>
-              </a:rPr>
-              <a:t>Underscores that personal administration and attention to detail are combat skills on which operational effectiveness depends.</a:t>
-            </a:r>
-          </a:p>
-          <a:p>
-            <a:pPr marL="457200" indent="-457200" algn="just">
+              <a:rPr sz="2600" b="0" u="none" i="0">
+                <a:solidFill>
+                  <a:schemeClr val="bg1"/>
+                </a:solidFill>
+                <a:latin typeface="Arial"/>
+                <a:cs typeface="Arial"/>
+              </a:rPr>
+              <a:t>Materials Used.</a:t>
+            </a:r>
+          </a:p>
+          <a:p>
+            <a:pPr marL="571500" indent="-571500" algn="l">
               <a:spcAft>
-                <a:spcPts val="1800"/>
+                <a:spcPts val="600"/>
               </a:spcAft>
               <a:buFont typeface="Arial"/>
-              <a:buChar char="•"/>
+              <a:buAutoNum type="arabicPeriod"/>
             </a:pPr>
             <a:r>
-              <a:rPr sz="2400" b="0" u="none" i="0">
-                <a:solidFill>
-                  <a:schemeClr val="bg1"/>
-                </a:solidFill>
-                <a:latin typeface="Arial"/>
-                <a:cs typeface="Arial"/>
-              </a:rPr>
-              <a:t>Shows that common standards build trust and interoperability in joint and multinational operations, as in GAF peace support missions.</a:t>
+              <a:rPr sz="2600" b="0" u="none" i="0">
+                <a:solidFill>
+                  <a:schemeClr val="bg1"/>
+                </a:solidFill>
+                <a:latin typeface="Arial"/>
+                <a:cs typeface="Arial"/>
+              </a:rPr>
+              <a:t>Facts Presented.</a:t>
+            </a:r>
+          </a:p>
+          <a:p>
+            <a:pPr marL="571500" indent="-571500" algn="l">
+              <a:spcAft>
+                <a:spcPts val="600"/>
+              </a:spcAft>
+              <a:buFont typeface="Arial"/>
+              <a:buAutoNum type="arabicPeriod"/>
+            </a:pPr>
+            <a:r>
+              <a:rPr sz="2600" b="0" u="none" i="0">
+                <a:solidFill>
+                  <a:schemeClr val="bg1"/>
+                </a:solidFill>
+                <a:latin typeface="Arial"/>
+                <a:cs typeface="Arial"/>
+              </a:rPr>
+              <a:t>Clarity.</a:t>
+            </a:r>
+          </a:p>
+          <a:p>
+            <a:pPr marL="571500" indent="-571500" algn="l">
+              <a:spcAft>
+                <a:spcPts val="600"/>
+              </a:spcAft>
+              <a:buFont typeface="Arial"/>
+              <a:buAutoNum type="arabicPeriod"/>
+            </a:pPr>
+            <a:r>
+              <a:rPr sz="2600" b="0" u="none" i="0">
+                <a:solidFill>
+                  <a:schemeClr val="bg1"/>
+                </a:solidFill>
+                <a:latin typeface="Arial"/>
+                <a:cs typeface="Arial"/>
+              </a:rPr>
+              <a:t>Readability.</a:t>
+            </a:r>
+          </a:p>
+          <a:p>
+            <a:pPr marL="571500" indent="-571500" algn="l">
+              <a:spcAft>
+                <a:spcPts val="600"/>
+              </a:spcAft>
+              <a:buFont typeface="Arial"/>
+              <a:buAutoNum type="arabicPeriod"/>
+            </a:pPr>
+            <a:r>
+              <a:rPr sz="2600" b="0" u="none" i="0">
+                <a:solidFill>
+                  <a:schemeClr val="bg1"/>
+                </a:solidFill>
+                <a:latin typeface="Arial"/>
+                <a:cs typeface="Arial"/>
+              </a:rPr>
+              <a:t>Mental Stimulation.</a:t>
+            </a:r>
+          </a:p>
+          <a:p>
+            <a:pPr marL="571500" indent="-571500" algn="l">
+              <a:spcAft>
+                <a:spcPts val="600"/>
+              </a:spcAft>
+              <a:buFont typeface="Arial"/>
+              <a:buAutoNum type="arabicPeriod"/>
+            </a:pPr>
+            <a:r>
+              <a:rPr sz="2600" b="0" u="none" i="0">
+                <a:solidFill>
+                  <a:schemeClr val="bg1"/>
+                </a:solidFill>
+                <a:latin typeface="Arial"/>
+                <a:cs typeface="Arial"/>
+              </a:rPr>
+              <a:t>Broad-mindedness.</a:t>
+            </a:r>
+          </a:p>
+          <a:p>
+            <a:pPr marL="571500" indent="-571500" algn="l">
+              <a:spcAft>
+                <a:spcPts val="600"/>
+              </a:spcAft>
+              <a:buFont typeface="Arial"/>
+              <a:buAutoNum type="arabicPeriod"/>
+            </a:pPr>
+            <a:r>
+              <a:rPr sz="2600" b="0" u="none" i="0">
+                <a:solidFill>
+                  <a:schemeClr val="bg1"/>
+                </a:solidFill>
+                <a:latin typeface="Arial"/>
+                <a:cs typeface="Arial"/>
+              </a:rPr>
+              <a:t>Inspiration.</a:t>
             </a:r>
           </a:p>
         </p:txBody>
@@ -4213,14 +4447,14 @@
       <p:grpSpPr/>
       <p:sp>
         <p:nvSpPr>
-          <p:cNvPr id="2" name="Title"/>
+          <p:cNvPr id="2" name="Section"/>
           <p:cNvSpPr txBox="1"/>
           <p:nvPr/>
         </p:nvSpPr>
         <p:spPr>
           <a:xfrm>
-            <a:off x="1051560" y="457200"/>
-            <a:ext cx="10085832" cy="594360"/>
+            <a:off x="914400" y="2651760"/>
+            <a:ext cx="10360152" cy="1463040"/>
           </a:xfrm>
           <a:prstGeom prst="rect">
             <a:avLst/>
@@ -4235,167 +4469,14 @@
           <a:p>
             <a:pPr algn="ctr"/>
             <a:r>
-              <a:rPr sz="2800" b="0" u="sng" i="0">
-                <a:solidFill>
-                  <a:schemeClr val="bg1"/>
-                </a:solidFill>
-                <a:latin typeface="Arial"/>
-                <a:cs typeface="Arial"/>
-              </a:rPr>
-              <a:t>LESSONS LEARNT (CONT)</a:t>
-            </a:r>
-          </a:p>
-        </p:txBody>
-      </p:sp>
-      <p:sp>
-        <p:nvSpPr>
-          <p:cNvPr id="3" name="Content"/>
-          <p:cNvSpPr txBox="1"/>
-          <p:nvPr/>
-        </p:nvSpPr>
-        <p:spPr>
-          <a:xfrm>
-            <a:off x="548640" y="1234440"/>
-            <a:ext cx="6400800" cy="5029200"/>
-          </a:xfrm>
-          <a:prstGeom prst="rect">
-            <a:avLst/>
-          </a:prstGeom>
-          <a:noFill/>
-        </p:spPr>
-        <p:txBody>
-          <a:bodyPr wrap="square">
-            <a:spAutoFit/>
-          </a:bodyPr>
-          <a:lstStyle/>
-          <a:p>
-            <a:pPr marL="457200" indent="-457200" algn="l">
-              <a:spcAft>
-                <a:spcPts val="1600"/>
-              </a:spcAft>
-              <a:buFont typeface="Arial"/>
-              <a:buChar char="•"/>
-            </a:pPr>
-            <a:r>
-              <a:rPr sz="2200" b="0" u="none" i="0">
-                <a:solidFill>
-                  <a:schemeClr val="bg1"/>
-                </a:solidFill>
-                <a:latin typeface="Arial"/>
-                <a:cs typeface="Arial"/>
-              </a:rPr>
-              <a:t>Highlights the value of leadership that combines firmness with fairness and assesses each soldier as a whole.</a:t>
-            </a:r>
-          </a:p>
-          <a:p>
-            <a:pPr marL="457200" indent="-457200" algn="l">
-              <a:spcAft>
-                <a:spcPts val="1600"/>
-              </a:spcAft>
-              <a:buFont typeface="Arial"/>
-              <a:buChar char="•"/>
-            </a:pPr>
-            <a:r>
-              <a:rPr sz="2200" b="0" u="none" i="0">
-                <a:solidFill>
-                  <a:schemeClr val="bg1"/>
-                </a:solidFill>
-                <a:latin typeface="Arial"/>
-                <a:cs typeface="Arial"/>
-              </a:rPr>
-              <a:t>Reveals that thorough orders, rehearsals and brief-backs sustain operations when communications fail.</a:t>
-            </a:r>
-          </a:p>
-          <a:p>
-            <a:pPr marL="457200" indent="-457200" algn="l">
-              <a:spcAft>
-                <a:spcPts val="1600"/>
-              </a:spcAft>
-              <a:buFont typeface="Arial"/>
-              <a:buChar char="•"/>
-            </a:pPr>
-            <a:r>
-              <a:rPr sz="2200" b="0" u="none" i="0">
-                <a:solidFill>
-                  <a:schemeClr val="bg1"/>
-                </a:solidFill>
-                <a:latin typeface="Arial"/>
-                <a:cs typeface="Arial"/>
-              </a:rPr>
-              <a:t>Illustrates that integrity is the bedrock of trust within a unit.</a:t>
-            </a:r>
-          </a:p>
-        </p:txBody>
-      </p:sp>
-      <p:pic>
-        <p:nvPicPr>
-          <p:cNvPr id="4" name="King's Squad" descr="kingsquad.jpg"/>
-          <p:cNvPicPr>
-            <a:picLocks noChangeAspect="1"/>
-          </p:cNvPicPr>
-          <p:nvPr/>
-        </p:nvPicPr>
-        <p:blipFill>
-          <a:blip r:embed="rId2"/>
-          <a:stretch>
-            <a:fillRect/>
-          </a:stretch>
-        </p:blipFill>
-        <p:spPr>
-          <a:xfrm>
-            <a:off x="7360920" y="1234440"/>
-            <a:ext cx="4188530" cy="4206240"/>
-          </a:xfrm>
-          <a:prstGeom prst="rect">
-            <a:avLst/>
-          </a:prstGeom>
-        </p:spPr>
-      </p:pic>
-      <p:sp>
-        <p:nvSpPr>
-          <p:cNvPr id="5" name="Caption"/>
-          <p:cNvSpPr txBox="1"/>
-          <p:nvPr/>
-        </p:nvSpPr>
-        <p:spPr>
-          <a:xfrm>
-            <a:off x="7040880" y="5486400"/>
-            <a:ext cx="4754880" cy="640080"/>
-          </a:xfrm>
-          <a:prstGeom prst="rect">
-            <a:avLst/>
-          </a:prstGeom>
-          <a:noFill/>
-        </p:spPr>
-        <p:txBody>
-          <a:bodyPr wrap="square">
-            <a:spAutoFit/>
-          </a:bodyPr>
-          <a:lstStyle/>
-          <a:p>
-            <a:pPr algn="ctr"/>
-            <a:r>
-              <a:rPr sz="1200" b="0" u="none" i="0">
-                <a:solidFill>
-                  <a:schemeClr val="bg1"/>
-                </a:solidFill>
-                <a:latin typeface="Arial"/>
-                <a:cs typeface="Arial"/>
-              </a:rPr>
-              <a:t>638 Troop, the King’s Squad, with their training team</a:t>
-            </a:r>
-          </a:p>
-          <a:p>
-            <a:pPr algn="ctr"/>
-            <a:r>
-              <a:rPr sz="1000" b="0" u="none" i="0">
-                <a:solidFill>
-                  <a:schemeClr val="bg1"/>
-                </a:solidFill>
-                <a:latin typeface="Arial"/>
-                <a:cs typeface="Arial"/>
-              </a:rPr>
-              <a:t>Source: McManners, H. (1994). Commando: Winning the Green Beret</a:t>
+              <a:rPr sz="3200" b="0" u="none" i="0">
+                <a:solidFill>
+                  <a:schemeClr val="bg1"/>
+                </a:solidFill>
+                <a:latin typeface="Arial"/>
+                <a:cs typeface="Arial"/>
+              </a:rPr>
+              <a:t>LESSONS LEARNT</a:t>
             </a:r>
           </a:p>
         </p:txBody>
@@ -4420,14 +4501,14 @@
       <p:grpSpPr/>
       <p:sp>
         <p:nvSpPr>
-          <p:cNvPr id="2" name="Section"/>
+          <p:cNvPr id="2" name="Title"/>
           <p:cNvSpPr txBox="1"/>
           <p:nvPr/>
         </p:nvSpPr>
         <p:spPr>
           <a:xfrm>
-            <a:off x="914400" y="2651760"/>
-            <a:ext cx="10360152" cy="1463040"/>
+            <a:off x="1051560" y="457200"/>
+            <a:ext cx="10085832" cy="594360"/>
           </a:xfrm>
           <a:prstGeom prst="rect">
             <a:avLst/>
@@ -4442,14 +4523,94 @@
           <a:p>
             <a:pPr algn="ctr"/>
             <a:r>
-              <a:rPr sz="3200" b="0" u="none" i="0">
-                <a:solidFill>
-                  <a:schemeClr val="bg1"/>
-                </a:solidFill>
-                <a:latin typeface="Arial"/>
-                <a:cs typeface="Arial"/>
-              </a:rPr>
-              <a:t>CONCLUSION</a:t>
+              <a:rPr sz="2800" b="0" u="sng" i="0">
+                <a:solidFill>
+                  <a:schemeClr val="bg1"/>
+                </a:solidFill>
+                <a:latin typeface="Arial"/>
+                <a:cs typeface="Arial"/>
+              </a:rPr>
+              <a:t>LESSONS LEARNT (CONT)</a:t>
+            </a:r>
+          </a:p>
+        </p:txBody>
+      </p:sp>
+      <p:sp>
+        <p:nvSpPr>
+          <p:cNvPr id="3" name="Content"/>
+          <p:cNvSpPr txBox="1"/>
+          <p:nvPr/>
+        </p:nvSpPr>
+        <p:spPr>
+          <a:xfrm>
+            <a:off x="548640" y="1234440"/>
+            <a:ext cx="11064240" cy="5029200"/>
+          </a:xfrm>
+          <a:prstGeom prst="rect">
+            <a:avLst/>
+          </a:prstGeom>
+          <a:noFill/>
+        </p:spPr>
+        <p:txBody>
+          <a:bodyPr wrap="square">
+            <a:spAutoFit/>
+          </a:bodyPr>
+          <a:lstStyle/>
+          <a:p>
+            <a:pPr marL="457200" indent="-457200" algn="just">
+              <a:spcAft>
+                <a:spcPts val="1800"/>
+              </a:spcAft>
+              <a:buFont typeface="Arial"/>
+              <a:buChar char="•"/>
+            </a:pPr>
+            <a:r>
+              <a:rPr sz="2400" b="0" u="none" i="0">
+                <a:solidFill>
+                  <a:schemeClr val="bg1"/>
+                </a:solidFill>
+                <a:latin typeface="Arial"/>
+                <a:cs typeface="Arial"/>
+              </a:rPr>
+              <a:t>Demonstrates that mental resilience, not physical strength alone, decides success under cold, fatigue and stress.</a:t>
+            </a:r>
+          </a:p>
+          <a:p>
+            <a:pPr marL="457200" indent="-457200" algn="just">
+              <a:spcAft>
+                <a:spcPts val="1800"/>
+              </a:spcAft>
+              <a:buFont typeface="Arial"/>
+              <a:buChar char="•"/>
+            </a:pPr>
+            <a:r>
+              <a:rPr sz="2400" b="0" u="none" i="0">
+                <a:solidFill>
+                  <a:schemeClr val="bg1"/>
+                </a:solidFill>
+                <a:latin typeface="Arial"/>
+                <a:cs typeface="Arial"/>
+              </a:rPr>
+              <a:t>Underscores that personal administration and attention to detail are combat skills on which operational effectiveness depends.</a:t>
+            </a:r>
+          </a:p>
+          <a:p>
+            <a:pPr marL="457200" indent="-457200" algn="just">
+              <a:spcAft>
+                <a:spcPts val="1800"/>
+              </a:spcAft>
+              <a:buFont typeface="Arial"/>
+              <a:buChar char="•"/>
+            </a:pPr>
+            <a:r>
+              <a:rPr sz="2400" b="0" u="none" i="0">
+                <a:solidFill>
+                  <a:schemeClr val="bg1"/>
+                </a:solidFill>
+                <a:latin typeface="Arial"/>
+                <a:cs typeface="Arial"/>
+              </a:rPr>
+              <a:t>Shows that common standards build trust and interoperability in joint and multinational operations, as in GAF peace support missions.</a:t>
             </a:r>
           </a:p>
         </p:txBody>
@@ -4474,14 +4635,14 @@
       <p:grpSpPr/>
       <p:sp>
         <p:nvSpPr>
-          <p:cNvPr id="2" name="Section"/>
+          <p:cNvPr id="2" name="Title"/>
           <p:cNvSpPr txBox="1"/>
           <p:nvPr/>
         </p:nvSpPr>
         <p:spPr>
           <a:xfrm>
-            <a:off x="914400" y="2651760"/>
-            <a:ext cx="10360152" cy="1463040"/>
+            <a:off x="1051560" y="457200"/>
+            <a:ext cx="10085832" cy="594360"/>
           </a:xfrm>
           <a:prstGeom prst="rect">
             <a:avLst/>
@@ -4496,14 +4657,167 @@
           <a:p>
             <a:pPr algn="ctr"/>
             <a:r>
-              <a:rPr sz="3200" b="0" u="none" i="0">
-                <a:solidFill>
-                  <a:schemeClr val="bg1"/>
-                </a:solidFill>
-                <a:latin typeface="Arial"/>
-                <a:cs typeface="Arial"/>
-              </a:rPr>
-              <a:t>THANK YOU</a:t>
+              <a:rPr sz="2800" b="0" u="sng" i="0">
+                <a:solidFill>
+                  <a:schemeClr val="bg1"/>
+                </a:solidFill>
+                <a:latin typeface="Arial"/>
+                <a:cs typeface="Arial"/>
+              </a:rPr>
+              <a:t>LESSONS LEARNT (CONT)</a:t>
+            </a:r>
+          </a:p>
+        </p:txBody>
+      </p:sp>
+      <p:sp>
+        <p:nvSpPr>
+          <p:cNvPr id="3" name="Content"/>
+          <p:cNvSpPr txBox="1"/>
+          <p:nvPr/>
+        </p:nvSpPr>
+        <p:spPr>
+          <a:xfrm>
+            <a:off x="548640" y="1234440"/>
+            <a:ext cx="6400800" cy="5029200"/>
+          </a:xfrm>
+          <a:prstGeom prst="rect">
+            <a:avLst/>
+          </a:prstGeom>
+          <a:noFill/>
+        </p:spPr>
+        <p:txBody>
+          <a:bodyPr wrap="square">
+            <a:spAutoFit/>
+          </a:bodyPr>
+          <a:lstStyle/>
+          <a:p>
+            <a:pPr marL="457200" indent="-457200" algn="l">
+              <a:spcAft>
+                <a:spcPts val="1600"/>
+              </a:spcAft>
+              <a:buFont typeface="Arial"/>
+              <a:buChar char="•"/>
+            </a:pPr>
+            <a:r>
+              <a:rPr sz="2200" b="0" u="none" i="0">
+                <a:solidFill>
+                  <a:schemeClr val="bg1"/>
+                </a:solidFill>
+                <a:latin typeface="Arial"/>
+                <a:cs typeface="Arial"/>
+              </a:rPr>
+              <a:t>Highlights the value of leadership that combines firmness with fairness and assesses each soldier as a whole.</a:t>
+            </a:r>
+          </a:p>
+          <a:p>
+            <a:pPr marL="457200" indent="-457200" algn="l">
+              <a:spcAft>
+                <a:spcPts val="1600"/>
+              </a:spcAft>
+              <a:buFont typeface="Arial"/>
+              <a:buChar char="•"/>
+            </a:pPr>
+            <a:r>
+              <a:rPr sz="2200" b="0" u="none" i="0">
+                <a:solidFill>
+                  <a:schemeClr val="bg1"/>
+                </a:solidFill>
+                <a:latin typeface="Arial"/>
+                <a:cs typeface="Arial"/>
+              </a:rPr>
+              <a:t>Reveals that thorough orders, rehearsals and brief-backs sustain operations when communications fail.</a:t>
+            </a:r>
+          </a:p>
+          <a:p>
+            <a:pPr marL="457200" indent="-457200" algn="l">
+              <a:spcAft>
+                <a:spcPts val="1600"/>
+              </a:spcAft>
+              <a:buFont typeface="Arial"/>
+              <a:buChar char="•"/>
+            </a:pPr>
+            <a:r>
+              <a:rPr sz="2200" b="0" u="none" i="0">
+                <a:solidFill>
+                  <a:schemeClr val="bg1"/>
+                </a:solidFill>
+                <a:latin typeface="Arial"/>
+                <a:cs typeface="Arial"/>
+              </a:rPr>
+              <a:t>Illustrates that integrity is the bedrock of trust within a unit.</a:t>
+            </a:r>
+          </a:p>
+        </p:txBody>
+      </p:sp>
+      <p:pic>
+        <p:nvPicPr>
+          <p:cNvPr id="4" name="King's Squad" descr="kingsquad.jpg"/>
+          <p:cNvPicPr>
+            <a:picLocks noChangeAspect="1"/>
+          </p:cNvPicPr>
+          <p:nvPr/>
+        </p:nvPicPr>
+        <p:blipFill>
+          <a:blip r:embed="rId2"/>
+          <a:stretch>
+            <a:fillRect/>
+          </a:stretch>
+        </p:blipFill>
+        <p:spPr>
+          <a:xfrm>
+            <a:off x="7360920" y="1234440"/>
+            <a:ext cx="4188530" cy="4206240"/>
+          </a:xfrm>
+          <a:prstGeom prst="rect">
+            <a:avLst/>
+          </a:prstGeom>
+        </p:spPr>
+      </p:pic>
+      <p:sp>
+        <p:nvSpPr>
+          <p:cNvPr id="5" name="Caption"/>
+          <p:cNvSpPr txBox="1"/>
+          <p:nvPr/>
+        </p:nvSpPr>
+        <p:spPr>
+          <a:xfrm>
+            <a:off x="7040880" y="5486400"/>
+            <a:ext cx="4754880" cy="640080"/>
+          </a:xfrm>
+          <a:prstGeom prst="rect">
+            <a:avLst/>
+          </a:prstGeom>
+          <a:noFill/>
+        </p:spPr>
+        <p:txBody>
+          <a:bodyPr wrap="square">
+            <a:spAutoFit/>
+          </a:bodyPr>
+          <a:lstStyle/>
+          <a:p>
+            <a:pPr algn="ctr"/>
+            <a:r>
+              <a:rPr sz="1200" b="0" u="none" i="0">
+                <a:solidFill>
+                  <a:schemeClr val="bg1"/>
+                </a:solidFill>
+                <a:latin typeface="Arial"/>
+                <a:cs typeface="Arial"/>
+              </a:rPr>
+              <a:t>638 Troop, the King’s Squad, with their training team</a:t>
+            </a:r>
+          </a:p>
+          <a:p>
+            <a:pPr algn="ctr"/>
+            <a:r>
+              <a:rPr sz="1000" b="0" u="none" i="0">
+                <a:solidFill>
+                  <a:schemeClr val="bg1"/>
+                </a:solidFill>
+                <a:latin typeface="Arial"/>
+                <a:cs typeface="Arial"/>
+              </a:rPr>
+              <a:t>Source: McManners, H. (1994). Commando: Winning the Green Beret</a:t>
             </a:r>
           </a:p>
         </p:txBody>
@@ -4528,14 +4842,14 @@
       <p:grpSpPr/>
       <p:sp>
         <p:nvSpPr>
-          <p:cNvPr id="2" name="Title"/>
+          <p:cNvPr id="2" name="Section"/>
           <p:cNvSpPr txBox="1"/>
           <p:nvPr/>
         </p:nvSpPr>
         <p:spPr>
           <a:xfrm>
-            <a:off x="1051560" y="411480"/>
-            <a:ext cx="10085832" cy="594360"/>
+            <a:off x="914400" y="2651760"/>
+            <a:ext cx="10360152" cy="1463040"/>
           </a:xfrm>
           <a:prstGeom prst="rect">
             <a:avLst/>
@@ -4550,210 +4864,14 @@
           <a:p>
             <a:pPr algn="ctr"/>
             <a:r>
-              <a:rPr sz="2800" b="0" u="sng" i="0">
-                <a:solidFill>
-                  <a:schemeClr val="bg1"/>
-                </a:solidFill>
-                <a:latin typeface="Arial"/>
-                <a:cs typeface="Arial"/>
-              </a:rPr>
-              <a:t>REFERENCES</a:t>
-            </a:r>
-          </a:p>
-        </p:txBody>
-      </p:sp>
-      <p:sp>
-        <p:nvSpPr>
-          <p:cNvPr id="3" name="Content"/>
-          <p:cNvSpPr txBox="1"/>
-          <p:nvPr/>
-        </p:nvSpPr>
-        <p:spPr>
-          <a:xfrm>
-            <a:off x="365760" y="1097280"/>
-            <a:ext cx="11430000" cy="5029200"/>
-          </a:xfrm>
-          <a:prstGeom prst="rect">
-            <a:avLst/>
-          </a:prstGeom>
-          <a:noFill/>
-        </p:spPr>
-        <p:txBody>
-          <a:bodyPr wrap="square">
-            <a:spAutoFit/>
-          </a:bodyPr>
-          <a:lstStyle/>
-          <a:p>
-            <a:pPr marL="571500" indent="-571500" algn="l">
-              <a:spcAft>
-                <a:spcPts val="600"/>
-              </a:spcAft>
-              <a:buFont typeface="Arial"/>
-              <a:buAutoNum type="arabicPeriod"/>
-            </a:pPr>
-            <a:r>
-              <a:rPr sz="1600" b="0" u="none" i="0">
-                <a:solidFill>
-                  <a:schemeClr val="bg1"/>
-                </a:solidFill>
-                <a:latin typeface="Arial"/>
-                <a:cs typeface="Arial"/>
-              </a:rPr>
-              <a:t>Commando Veterans Archive. (n.d.). Falklands Campaign – Mention in Despatches. Retrieved from: https://www.commandoveterans.org/node/5568</a:t>
-            </a:r>
-          </a:p>
-          <a:p>
-            <a:pPr marL="571500" indent="-571500" algn="l">
-              <a:spcAft>
-                <a:spcPts val="600"/>
-              </a:spcAft>
-              <a:buFont typeface="Arial"/>
-              <a:buAutoNum type="arabicPeriod"/>
-            </a:pPr>
-            <a:r>
-              <a:rPr sz="1600" b="0" u="none" i="0">
-                <a:solidFill>
-                  <a:schemeClr val="bg1"/>
-                </a:solidFill>
-                <a:latin typeface="Arial"/>
-                <a:cs typeface="Arial"/>
-              </a:rPr>
-              <a:t>Commando Veterans Archive. (2013). The Four Commando Tests. Retrieved from: https://www.commandoveterans.org/node/5093</a:t>
-            </a:r>
-          </a:p>
-          <a:p>
-            <a:pPr marL="571500" indent="-571500" algn="l">
-              <a:spcAft>
-                <a:spcPts val="600"/>
-              </a:spcAft>
-              <a:buFont typeface="Arial"/>
-              <a:buAutoNum type="arabicPeriod"/>
-            </a:pPr>
-            <a:r>
-              <a:rPr sz="1600" b="0" u="none" i="0">
-                <a:solidFill>
-                  <a:schemeClr val="bg1"/>
-                </a:solidFill>
-                <a:latin typeface="Arial"/>
-                <a:cs typeface="Arial"/>
-              </a:rPr>
-              <a:t>McManners, H. (1994). </a:t>
-            </a:r>
-            <a:r>
-              <a:rPr sz="1600" b="0" u="none" i="1">
-                <a:solidFill>
-                  <a:schemeClr val="bg1"/>
-                </a:solidFill>
-                <a:latin typeface="Arial"/>
-                <a:cs typeface="Arial"/>
-              </a:rPr>
-              <a:t>Commando: Winning the Green Beret</a:t>
-            </a:r>
-            <a:r>
-              <a:rPr sz="1600" b="0" u="none" i="0">
-                <a:solidFill>
-                  <a:schemeClr val="bg1"/>
-                </a:solidFill>
-                <a:latin typeface="Arial"/>
-                <a:cs typeface="Arial"/>
-              </a:rPr>
-              <a:t>. London: Network Books (BBC Books).</a:t>
-            </a:r>
-          </a:p>
-          <a:p>
-            <a:pPr marL="571500" indent="-571500" algn="l">
-              <a:spcAft>
-                <a:spcPts val="600"/>
-              </a:spcAft>
-              <a:buFont typeface="Arial"/>
-              <a:buAutoNum type="arabicPeriod"/>
-            </a:pPr>
-            <a:r>
-              <a:rPr sz="1600" b="0" u="none" i="0">
-                <a:solidFill>
-                  <a:schemeClr val="bg1"/>
-                </a:solidFill>
-                <a:latin typeface="Arial"/>
-                <a:cs typeface="Arial"/>
-              </a:rPr>
-              <a:t>Melbourne University Publishing. (n.d.). Author profile: Hugh McManners. Retrieved from: https://mup.com.au/authors/hugh-mcmanners</a:t>
-            </a:r>
-          </a:p>
-          <a:p>
-            <a:pPr marL="571500" indent="-571500" algn="l">
-              <a:spcAft>
-                <a:spcPts val="600"/>
-              </a:spcAft>
-              <a:buFont typeface="Arial"/>
-              <a:buAutoNum type="arabicPeriod"/>
-            </a:pPr>
-            <a:r>
-              <a:rPr sz="1600" b="0" u="none" i="0">
-                <a:solidFill>
-                  <a:schemeClr val="bg1"/>
-                </a:solidFill>
-                <a:latin typeface="Arial"/>
-                <a:cs typeface="Arial"/>
-              </a:rPr>
-              <a:t>Publishers Weekly. (1995). Review of </a:t>
-            </a:r>
-            <a:r>
-              <a:rPr sz="1600" b="0" u="none" i="1">
-                <a:solidFill>
-                  <a:schemeClr val="bg1"/>
-                </a:solidFill>
-                <a:latin typeface="Arial"/>
-                <a:cs typeface="Arial"/>
-              </a:rPr>
-              <a:t>Commando</a:t>
-            </a:r>
-            <a:r>
-              <a:rPr sz="1600" b="0" u="none" i="0">
-                <a:solidFill>
-                  <a:schemeClr val="bg1"/>
-                </a:solidFill>
-                <a:latin typeface="Arial"/>
-                <a:cs typeface="Arial"/>
-              </a:rPr>
-              <a:t> by Hugh McManners. Retrieved from: https://www.publishersweekly.com/9780563369813</a:t>
-            </a:r>
-          </a:p>
-          <a:p>
-            <a:pPr marL="571500" indent="-571500" algn="l">
-              <a:spcAft>
-                <a:spcPts val="600"/>
-              </a:spcAft>
-              <a:buFont typeface="Arial"/>
-              <a:buAutoNum type="arabicPeriod"/>
-            </a:pPr>
-            <a:r>
-              <a:rPr sz="1600" b="0" u="none" i="0">
-                <a:solidFill>
-                  <a:schemeClr val="bg1"/>
-                </a:solidFill>
-                <a:latin typeface="Arial"/>
-                <a:cs typeface="Arial"/>
-              </a:rPr>
-              <a:t>Royal Marines History. (2020). HM King George V, The King’s Squad &amp; King’s Badge. Retrieved from: https://www.royalmarineshistory.com</a:t>
-            </a:r>
-          </a:p>
-          <a:p>
-            <a:pPr marL="571500" indent="-571500" algn="l">
-              <a:spcAft>
-                <a:spcPts val="600"/>
-              </a:spcAft>
-              <a:buFont typeface="Arial"/>
-              <a:buAutoNum type="arabicPeriod"/>
-            </a:pPr>
-            <a:r>
-              <a:rPr sz="1600" b="0" u="none" i="0">
-                <a:solidFill>
-                  <a:schemeClr val="bg1"/>
-                </a:solidFill>
-                <a:latin typeface="Arial"/>
-                <a:cs typeface="Arial"/>
-              </a:rPr>
-              <a:t>Wikipedia. (n.d.). Hugh McManners. Retrieved from: https://en.wikipedia.org/wiki/Hugh_McManners</a:t>
+              <a:rPr sz="3200" b="0" u="none" i="0">
+                <a:solidFill>
+                  <a:schemeClr val="bg1"/>
+                </a:solidFill>
+                <a:latin typeface="Arial"/>
+                <a:cs typeface="Arial"/>
+              </a:rPr>
+              <a:t>CONCLUSION</a:t>
             </a:r>
           </a:p>
         </p:txBody>
@@ -4807,6 +4925,310 @@
                 <a:latin typeface="Arial"/>
                 <a:cs typeface="Arial"/>
               </a:rPr>
+              <a:t>THANK YOU</a:t>
+            </a:r>
+          </a:p>
+        </p:txBody>
+      </p:sp>
+    </p:spTree>
+  </p:cSld>
+  <p:clrMapOvr>
+    <a:masterClrMapping/>
+  </p:clrMapOvr>
+</p:sld>
+</file>
+
+<file path=ppt/slides/slide26.xml><?xml version="1.0" encoding="utf-8"?>
+<p:sld xmlns:a="http://schemas.openxmlformats.org/drawingml/2006/main" xmlns:p="http://schemas.openxmlformats.org/presentationml/2006/main" xmlns:r="http://schemas.openxmlformats.org/officeDocument/2006/relationships">
+  <p:cSld>
+    <p:spTree>
+      <p:nvGrpSpPr>
+        <p:cNvPr id="1" name=""/>
+        <p:cNvGrpSpPr/>
+        <p:nvPr/>
+      </p:nvGrpSpPr>
+      <p:grpSpPr/>
+      <p:sp>
+        <p:nvSpPr>
+          <p:cNvPr id="2" name="Title"/>
+          <p:cNvSpPr txBox="1"/>
+          <p:nvPr/>
+        </p:nvSpPr>
+        <p:spPr>
+          <a:xfrm>
+            <a:off x="1051560" y="411480"/>
+            <a:ext cx="10085832" cy="594360"/>
+          </a:xfrm>
+          <a:prstGeom prst="rect">
+            <a:avLst/>
+          </a:prstGeom>
+          <a:noFill/>
+        </p:spPr>
+        <p:txBody>
+          <a:bodyPr wrap="square" anchor="ctr">
+            <a:spAutoFit/>
+          </a:bodyPr>
+          <a:lstStyle/>
+          <a:p>
+            <a:pPr algn="ctr"/>
+            <a:r>
+              <a:rPr sz="2800" b="0" u="sng" i="0">
+                <a:solidFill>
+                  <a:schemeClr val="bg1"/>
+                </a:solidFill>
+                <a:latin typeface="Arial"/>
+                <a:cs typeface="Arial"/>
+              </a:rPr>
+              <a:t>REFERENCES</a:t>
+            </a:r>
+          </a:p>
+        </p:txBody>
+      </p:sp>
+      <p:sp>
+        <p:nvSpPr>
+          <p:cNvPr id="3" name="Content"/>
+          <p:cNvSpPr txBox="1"/>
+          <p:nvPr/>
+        </p:nvSpPr>
+        <p:spPr>
+          <a:xfrm>
+            <a:off x="365760" y="1097280"/>
+            <a:ext cx="11430000" cy="5029200"/>
+          </a:xfrm>
+          <a:prstGeom prst="rect">
+            <a:avLst/>
+          </a:prstGeom>
+          <a:noFill/>
+        </p:spPr>
+        <p:txBody>
+          <a:bodyPr wrap="square">
+            <a:spAutoFit/>
+          </a:bodyPr>
+          <a:lstStyle/>
+          <a:p>
+            <a:pPr marL="571500" indent="-571500" algn="l">
+              <a:spcAft>
+                <a:spcPts val="600"/>
+              </a:spcAft>
+              <a:buFont typeface="Arial"/>
+              <a:buAutoNum type="arabicPeriod"/>
+            </a:pPr>
+            <a:r>
+              <a:rPr sz="1600" b="0" u="none" i="0">
+                <a:solidFill>
+                  <a:schemeClr val="bg1"/>
+                </a:solidFill>
+                <a:latin typeface="Arial"/>
+                <a:cs typeface="Arial"/>
+              </a:rPr>
+              <a:t>Commando Veterans Archive. (n.d.). Falklands Campaign – Mention in Despatches. Retrieved from: https://www.commandoveterans.org/node/5568</a:t>
+            </a:r>
+          </a:p>
+          <a:p>
+            <a:pPr marL="571500" indent="-571500" algn="l">
+              <a:spcAft>
+                <a:spcPts val="600"/>
+              </a:spcAft>
+              <a:buFont typeface="Arial"/>
+              <a:buAutoNum type="arabicPeriod"/>
+            </a:pPr>
+            <a:r>
+              <a:rPr sz="1600" b="0" u="none" i="0">
+                <a:solidFill>
+                  <a:schemeClr val="bg1"/>
+                </a:solidFill>
+                <a:latin typeface="Arial"/>
+                <a:cs typeface="Arial"/>
+              </a:rPr>
+              <a:t>Commando Veterans Archive. (2013). The Four Commando Tests. Retrieved from: https://www.commandoveterans.org/node/5093</a:t>
+            </a:r>
+          </a:p>
+          <a:p>
+            <a:pPr marL="571500" indent="-571500" algn="l">
+              <a:spcAft>
+                <a:spcPts val="600"/>
+              </a:spcAft>
+              <a:buFont typeface="Arial"/>
+              <a:buAutoNum type="arabicPeriod"/>
+            </a:pPr>
+            <a:r>
+              <a:rPr sz="1600" b="0" u="none" i="0">
+                <a:solidFill>
+                  <a:schemeClr val="bg1"/>
+                </a:solidFill>
+                <a:latin typeface="Arial"/>
+                <a:cs typeface="Arial"/>
+              </a:rPr>
+              <a:t>McManners, H. (1994). </a:t>
+            </a:r>
+            <a:r>
+              <a:rPr sz="1600" b="0" u="none" i="1">
+                <a:solidFill>
+                  <a:schemeClr val="bg1"/>
+                </a:solidFill>
+                <a:latin typeface="Arial"/>
+                <a:cs typeface="Arial"/>
+              </a:rPr>
+              <a:t>Commando: Winning the Green Beret</a:t>
+            </a:r>
+            <a:r>
+              <a:rPr sz="1600" b="0" u="none" i="0">
+                <a:solidFill>
+                  <a:schemeClr val="bg1"/>
+                </a:solidFill>
+                <a:latin typeface="Arial"/>
+                <a:cs typeface="Arial"/>
+              </a:rPr>
+              <a:t>. London: Network Books (BBC Books).</a:t>
+            </a:r>
+          </a:p>
+          <a:p>
+            <a:pPr marL="571500" indent="-571500" algn="l">
+              <a:spcAft>
+                <a:spcPts val="600"/>
+              </a:spcAft>
+              <a:buFont typeface="Arial"/>
+              <a:buAutoNum type="arabicPeriod"/>
+            </a:pPr>
+            <a:r>
+              <a:rPr sz="1600" b="0" u="none" i="0">
+                <a:solidFill>
+                  <a:schemeClr val="bg1"/>
+                </a:solidFill>
+                <a:latin typeface="Arial"/>
+                <a:cs typeface="Arial"/>
+              </a:rPr>
+              <a:t>Melbourne University Publishing. (n.d.). Author profile: Hugh McManners. Retrieved from: https://mup.com.au/authors/hugh-mcmanners</a:t>
+            </a:r>
+          </a:p>
+          <a:p>
+            <a:pPr marL="571500" indent="-571500" algn="l">
+              <a:spcAft>
+                <a:spcPts val="600"/>
+              </a:spcAft>
+              <a:buFont typeface="Arial"/>
+              <a:buAutoNum type="arabicPeriod"/>
+            </a:pPr>
+            <a:r>
+              <a:rPr sz="1600" b="0" u="none" i="0">
+                <a:solidFill>
+                  <a:schemeClr val="bg1"/>
+                </a:solidFill>
+                <a:latin typeface="Arial"/>
+                <a:cs typeface="Arial"/>
+              </a:rPr>
+              <a:t>Publishers Weekly. (1995). Review of </a:t>
+            </a:r>
+            <a:r>
+              <a:rPr sz="1600" b="0" u="none" i="1">
+                <a:solidFill>
+                  <a:schemeClr val="bg1"/>
+                </a:solidFill>
+                <a:latin typeface="Arial"/>
+                <a:cs typeface="Arial"/>
+              </a:rPr>
+              <a:t>Commando</a:t>
+            </a:r>
+            <a:r>
+              <a:rPr sz="1600" b="0" u="none" i="0">
+                <a:solidFill>
+                  <a:schemeClr val="bg1"/>
+                </a:solidFill>
+                <a:latin typeface="Arial"/>
+                <a:cs typeface="Arial"/>
+              </a:rPr>
+              <a:t> by Hugh McManners. Retrieved from: https://www.publishersweekly.com/9780563369813</a:t>
+            </a:r>
+          </a:p>
+          <a:p>
+            <a:pPr marL="571500" indent="-571500" algn="l">
+              <a:spcAft>
+                <a:spcPts val="600"/>
+              </a:spcAft>
+              <a:buFont typeface="Arial"/>
+              <a:buAutoNum type="arabicPeriod"/>
+            </a:pPr>
+            <a:r>
+              <a:rPr sz="1600" b="0" u="none" i="0">
+                <a:solidFill>
+                  <a:schemeClr val="bg1"/>
+                </a:solidFill>
+                <a:latin typeface="Arial"/>
+                <a:cs typeface="Arial"/>
+              </a:rPr>
+              <a:t>Royal Marines History. (2020). HM King George V, The King’s Squad &amp; King’s Badge. Retrieved from: https://www.royalmarineshistory.com</a:t>
+            </a:r>
+          </a:p>
+          <a:p>
+            <a:pPr marL="571500" indent="-571500" algn="l">
+              <a:spcAft>
+                <a:spcPts val="600"/>
+              </a:spcAft>
+              <a:buFont typeface="Arial"/>
+              <a:buAutoNum type="arabicPeriod"/>
+            </a:pPr>
+            <a:r>
+              <a:rPr sz="1600" b="0" u="none" i="0">
+                <a:solidFill>
+                  <a:schemeClr val="bg1"/>
+                </a:solidFill>
+                <a:latin typeface="Arial"/>
+                <a:cs typeface="Arial"/>
+              </a:rPr>
+              <a:t>Wikipedia. (n.d.). Hugh McManners. Retrieved from: https://en.wikipedia.org/wiki/Hugh_McManners</a:t>
+            </a:r>
+          </a:p>
+        </p:txBody>
+      </p:sp>
+    </p:spTree>
+  </p:cSld>
+  <p:clrMapOvr>
+    <a:masterClrMapping/>
+  </p:clrMapOvr>
+</p:sld>
+</file>
+
+<file path=ppt/slides/slide27.xml><?xml version="1.0" encoding="utf-8"?>
+<p:sld xmlns:a="http://schemas.openxmlformats.org/drawingml/2006/main" xmlns:p="http://schemas.openxmlformats.org/presentationml/2006/main" xmlns:r="http://schemas.openxmlformats.org/officeDocument/2006/relationships">
+  <p:cSld>
+    <p:spTree>
+      <p:nvGrpSpPr>
+        <p:cNvPr id="1" name=""/>
+        <p:cNvGrpSpPr/>
+        <p:nvPr/>
+      </p:nvGrpSpPr>
+      <p:grpSpPr/>
+      <p:sp>
+        <p:nvSpPr>
+          <p:cNvPr id="2" name="Section"/>
+          <p:cNvSpPr txBox="1"/>
+          <p:nvPr/>
+        </p:nvSpPr>
+        <p:spPr>
+          <a:xfrm>
+            <a:off x="914400" y="2651760"/>
+            <a:ext cx="10360152" cy="1463040"/>
+          </a:xfrm>
+          <a:prstGeom prst="rect">
+            <a:avLst/>
+          </a:prstGeom>
+          <a:noFill/>
+        </p:spPr>
+        <p:txBody>
+          <a:bodyPr wrap="square" anchor="ctr">
+            <a:spAutoFit/>
+          </a:bodyPr>
+          <a:lstStyle/>
+          <a:p>
+            <a:pPr algn="ctr"/>
+            <a:r>
+              <a:rPr sz="3200" b="0" u="none" i="0">
+                <a:solidFill>
+                  <a:schemeClr val="bg1"/>
+                </a:solidFill>
+                <a:latin typeface="Arial"/>
+                <a:cs typeface="Arial"/>
+              </a:rPr>
               <a:t>QUESTION AND CONTRIBUTIONS</a:t>
             </a:r>
           </a:p>
@@ -5496,8 +5918,8 @@
         </p:nvSpPr>
         <p:spPr>
           <a:xfrm>
-            <a:off x="548640" y="1234440"/>
-            <a:ext cx="11064240" cy="5029200"/>
+            <a:off x="457200" y="1234440"/>
+            <a:ext cx="8138160" cy="5029200"/>
           </a:xfrm>
           <a:prstGeom prst="rect">
             <a:avLst/>
@@ -5517,7 +5939,7 @@
               <a:buNone/>
             </a:pPr>
             <a:r>
-              <a:rPr sz="2000" b="0" u="sng" i="0">
+              <a:rPr sz="1800" b="0" u="sng" i="0">
                 <a:solidFill>
                   <a:schemeClr val="bg1"/>
                 </a:solidFill>
@@ -5530,13 +5952,13 @@
           <a:p>
             <a:pPr marL="457200" indent="-457200" algn="just">
               <a:spcAft>
-                <a:spcPts val="800"/>
+                <a:spcPts val="600"/>
               </a:spcAft>
               <a:buFont typeface="Arial"/>
               <a:buChar char="•"/>
             </a:pPr>
             <a:r>
-              <a:rPr sz="2000" b="0" u="none" i="0">
+              <a:rPr sz="1800" b="0" u="none" i="0">
                 <a:solidFill>
                   <a:schemeClr val="bg1"/>
                 </a:solidFill>
@@ -5549,13 +5971,13 @@
           <a:p>
             <a:pPr marL="457200" indent="-457200" algn="just">
               <a:spcAft>
-                <a:spcPts val="800"/>
+                <a:spcPts val="600"/>
               </a:spcAft>
               <a:buFont typeface="Arial"/>
               <a:buChar char="•"/>
             </a:pPr>
             <a:r>
-              <a:rPr sz="2000" b="0" u="none" i="0">
+              <a:rPr sz="1800" b="0" u="none" i="0">
                 <a:solidFill>
                   <a:schemeClr val="bg1"/>
                 </a:solidFill>
@@ -5568,13 +5990,13 @@
           <a:p>
             <a:pPr marL="457200" indent="-457200" algn="just">
               <a:spcAft>
-                <a:spcPts val="800"/>
+                <a:spcPts val="600"/>
               </a:spcAft>
               <a:buFont typeface="Arial"/>
               <a:buChar char="•"/>
             </a:pPr>
             <a:r>
-              <a:rPr sz="2000" b="0" u="none" i="0">
+              <a:rPr sz="1800" b="0" u="none" i="0">
                 <a:solidFill>
                   <a:schemeClr val="bg1"/>
                 </a:solidFill>
@@ -5587,13 +6009,13 @@
           <a:p>
             <a:pPr marL="457200" indent="-457200" algn="just">
               <a:spcAft>
-                <a:spcPts val="800"/>
+                <a:spcPts val="600"/>
               </a:spcAft>
               <a:buFont typeface="Arial"/>
               <a:buChar char="•"/>
             </a:pPr>
             <a:r>
-              <a:rPr sz="2000" b="0" u="none" i="0">
+              <a:rPr sz="1800" b="0" u="none" i="0">
                 <a:solidFill>
                   <a:schemeClr val="bg1"/>
                 </a:solidFill>
@@ -5606,13 +6028,13 @@
           <a:p>
             <a:pPr marL="457200" indent="-457200" algn="just">
               <a:spcAft>
-                <a:spcPts val="800"/>
+                <a:spcPts val="600"/>
               </a:spcAft>
               <a:buFont typeface="Arial"/>
               <a:buChar char="•"/>
             </a:pPr>
             <a:r>
-              <a:rPr sz="2000" b="0" u="none" i="0">
+              <a:rPr sz="1800" b="0" u="none" i="0">
                 <a:solidFill>
                   <a:schemeClr val="bg1"/>
                 </a:solidFill>
@@ -5625,13 +6047,13 @@
           <a:p>
             <a:pPr marL="457200" indent="-457200" algn="just">
               <a:spcAft>
-                <a:spcPts val="800"/>
+                <a:spcPts val="600"/>
               </a:spcAft>
               <a:buFont typeface="Arial"/>
               <a:buChar char="•"/>
             </a:pPr>
             <a:r>
-              <a:rPr sz="2000" b="0" u="none" i="0">
+              <a:rPr sz="1800" b="0" u="none" i="0">
                 <a:solidFill>
                   <a:schemeClr val="bg1"/>
                 </a:solidFill>
@@ -5644,13 +6066,13 @@
           <a:p>
             <a:pPr marL="457200" indent="-457200" algn="just">
               <a:spcAft>
-                <a:spcPts val="800"/>
+                <a:spcPts val="600"/>
               </a:spcAft>
               <a:buFont typeface="Arial"/>
               <a:buChar char="•"/>
             </a:pPr>
             <a:r>
-              <a:rPr sz="2000" b="0" u="none" i="0">
+              <a:rPr sz="1800" b="0" u="none" i="0">
                 <a:solidFill>
                   <a:schemeClr val="bg1"/>
                 </a:solidFill>
@@ -5658,6 +6080,79 @@
                 <a:cs typeface="Arial"/>
               </a:rPr>
               <a:t>Left the Army as a Major in 1989 after some 13 years with 3 Commando Brigade.</a:t>
+            </a:r>
+          </a:p>
+        </p:txBody>
+      </p:sp>
+      <p:pic>
+        <p:nvPicPr>
+          <p:cNvPr id="4" name="Author photo" descr="u4.jpg"/>
+          <p:cNvPicPr>
+            <a:picLocks noChangeAspect="1"/>
+          </p:cNvPicPr>
+          <p:nvPr/>
+        </p:nvPicPr>
+        <p:blipFill>
+          <a:blip r:embed="rId2"/>
+          <a:stretch>
+            <a:fillRect/>
+          </a:stretch>
+        </p:blipFill>
+        <p:spPr>
+          <a:xfrm>
+            <a:off x="9006840" y="1325880"/>
+            <a:ext cx="2651760" cy="2663868"/>
+          </a:xfrm>
+          <a:prstGeom prst="rect">
+            <a:avLst/>
+          </a:prstGeom>
+        </p:spPr>
+      </p:pic>
+      <p:sp>
+        <p:nvSpPr>
+          <p:cNvPr id="5" name="Caption"/>
+          <p:cNvSpPr txBox="1"/>
+          <p:nvPr/>
+        </p:nvSpPr>
+        <p:spPr>
+          <a:xfrm>
+            <a:off x="8641080" y="4069080"/>
+            <a:ext cx="3383280" cy="640080"/>
+          </a:xfrm>
+          <a:prstGeom prst="rect">
+            <a:avLst/>
+          </a:prstGeom>
+          <a:noFill/>
+        </p:spPr>
+        <p:txBody>
+          <a:bodyPr wrap="square">
+            <a:spAutoFit/>
+          </a:bodyPr>
+          <a:lstStyle/>
+          <a:p>
+            <a:pPr algn="ctr"/>
+            <a:r>
+              <a:rPr sz="1200" b="0" u="none" i="0">
+                <a:solidFill>
+                  <a:schemeClr val="bg1"/>
+                </a:solidFill>
+                <a:latin typeface="Arial"/>
+                <a:cs typeface="Arial"/>
+              </a:rPr>
+              <a:t>Hugh McManners</a:t>
+            </a:r>
+          </a:p>
+          <a:p>
+            <a:pPr algn="ctr"/>
+            <a:r>
+              <a:rPr sz="1000" b="0" u="none" i="0">
+                <a:solidFill>
+                  <a:schemeClr val="bg1"/>
+                </a:solidFill>
+                <a:latin typeface="Arial"/>
+                <a:cs typeface="Arial"/>
+              </a:rPr>
+              <a:t>Source: https://www.google.com/search</a:t>
             </a:r>
           </a:p>
         </p:txBody>
@@ -5724,8 +6219,8 @@
         </p:nvSpPr>
         <p:spPr>
           <a:xfrm>
-            <a:off x="548640" y="1234440"/>
-            <a:ext cx="11064240" cy="5029200"/>
+            <a:off x="457200" y="1234440"/>
+            <a:ext cx="8138160" cy="5029200"/>
           </a:xfrm>
           <a:prstGeom prst="rect">
             <a:avLst/>
@@ -5745,7 +6240,7 @@
               <a:buNone/>
             </a:pPr>
             <a:r>
-              <a:rPr sz="2200" b="0" u="sng" i="0">
+              <a:rPr sz="2000" b="0" u="sng" i="0">
                 <a:solidFill>
                   <a:schemeClr val="bg1"/>
                 </a:solidFill>
@@ -5756,15 +6251,15 @@
             </a:r>
           </a:p>
           <a:p>
-            <a:pPr marL="457200" indent="-457200" algn="just">
+            <a:pPr marL="457200" indent="-457200" algn="l">
               <a:spcAft>
-                <a:spcPts val="1200"/>
+                <a:spcPts val="1000"/>
               </a:spcAft>
               <a:buFont typeface="Arial"/>
               <a:buChar char="•"/>
             </a:pPr>
             <a:r>
-              <a:rPr sz="2200" b="0" u="none" i="0">
+              <a:rPr sz="2000" b="0" u="none" i="0">
                 <a:solidFill>
                   <a:schemeClr val="bg1"/>
                 </a:solidFill>
@@ -5775,15 +6270,15 @@
             </a:r>
           </a:p>
           <a:p>
-            <a:pPr marL="457200" indent="-457200" algn="just">
+            <a:pPr marL="457200" indent="-457200" algn="l">
               <a:spcAft>
-                <a:spcPts val="1200"/>
+                <a:spcPts val="1000"/>
               </a:spcAft>
               <a:buFont typeface="Arial"/>
               <a:buChar char="•"/>
             </a:pPr>
             <a:r>
-              <a:rPr sz="2200" b="0" u="none" i="0">
+              <a:rPr sz="2000" b="0" u="none" i="0">
                 <a:solidFill>
                   <a:schemeClr val="bg1"/>
                 </a:solidFill>
@@ -5794,15 +6289,15 @@
             </a:r>
           </a:p>
           <a:p>
-            <a:pPr marL="457200" indent="-457200" algn="just">
+            <a:pPr marL="457200" indent="-457200" algn="l">
               <a:spcAft>
-                <a:spcPts val="1200"/>
+                <a:spcPts val="1000"/>
               </a:spcAft>
               <a:buFont typeface="Arial"/>
               <a:buChar char="•"/>
             </a:pPr>
             <a:r>
-              <a:rPr sz="2200" b="0" u="none" i="0">
+              <a:rPr sz="2000" b="0" u="none" i="0">
                 <a:solidFill>
                   <a:schemeClr val="bg1"/>
                 </a:solidFill>
@@ -5813,15 +6308,15 @@
             </a:r>
           </a:p>
           <a:p>
-            <a:pPr marL="457200" indent="-457200" algn="just">
+            <a:pPr marL="457200" indent="-457200" algn="l">
               <a:spcAft>
-                <a:spcPts val="1200"/>
+                <a:spcPts val="1000"/>
               </a:spcAft>
               <a:buFont typeface="Arial"/>
               <a:buChar char="•"/>
             </a:pPr>
             <a:r>
-              <a:rPr sz="2200" b="0" u="none" i="0">
+              <a:rPr sz="2000" b="0" u="none" i="0">
                 <a:solidFill>
                   <a:schemeClr val="bg1"/>
                 </a:solidFill>
@@ -5829,6 +6324,79 @@
                 <a:cs typeface="Arial"/>
               </a:rPr>
               <a:t>Author of some fifteen books, including “Falklands Commando” (1984), “The Scars of War” (1993), “The Commando Survival Manual”, “Ultimate Special Forces” and “Forgotten Voices of the Falklands” (2007).</a:t>
+            </a:r>
+          </a:p>
+        </p:txBody>
+      </p:sp>
+      <p:pic>
+        <p:nvPicPr>
+          <p:cNvPr id="4" name="Author photo" descr="u5.jpg"/>
+          <p:cNvPicPr>
+            <a:picLocks noChangeAspect="1"/>
+          </p:cNvPicPr>
+          <p:nvPr/>
+        </p:nvPicPr>
+        <p:blipFill>
+          <a:blip r:embed="rId2"/>
+          <a:stretch>
+            <a:fillRect/>
+          </a:stretch>
+        </p:blipFill>
+        <p:spPr>
+          <a:xfrm>
+            <a:off x="9006840" y="1325880"/>
+            <a:ext cx="2651760" cy="2651760"/>
+          </a:xfrm>
+          <a:prstGeom prst="rect">
+            <a:avLst/>
+          </a:prstGeom>
+        </p:spPr>
+      </p:pic>
+      <p:sp>
+        <p:nvSpPr>
+          <p:cNvPr id="5" name="Caption"/>
+          <p:cNvSpPr txBox="1"/>
+          <p:nvPr/>
+        </p:nvSpPr>
+        <p:spPr>
+          <a:xfrm>
+            <a:off x="8641080" y="4069080"/>
+            <a:ext cx="3383280" cy="640080"/>
+          </a:xfrm>
+          <a:prstGeom prst="rect">
+            <a:avLst/>
+          </a:prstGeom>
+          <a:noFill/>
+        </p:spPr>
+        <p:txBody>
+          <a:bodyPr wrap="square">
+            <a:spAutoFit/>
+          </a:bodyPr>
+          <a:lstStyle/>
+          <a:p>
+            <a:pPr algn="ctr"/>
+            <a:r>
+              <a:rPr sz="1200" b="0" u="none" i="0">
+                <a:solidFill>
+                  <a:schemeClr val="bg1"/>
+                </a:solidFill>
+                <a:latin typeface="Arial"/>
+                <a:cs typeface="Arial"/>
+              </a:rPr>
+              <a:t>Hugh McManners</a:t>
+            </a:r>
+          </a:p>
+          <a:p>
+            <a:pPr algn="ctr"/>
+            <a:r>
+              <a:rPr sz="1000" b="0" u="none" i="0">
+                <a:solidFill>
+                  <a:schemeClr val="bg1"/>
+                </a:solidFill>
+                <a:latin typeface="Arial"/>
+                <a:cs typeface="Arial"/>
+              </a:rPr>
+              <a:t>Source: https://www.google.com/search</a:t>
             </a:r>
           </a:p>
         </p:txBody>

</xml_diff>

<commit_message>
Add 10-minute presentation script and load it into speaker notes
Co-Authored-By: Claude Opus 5.5 <noreply@anthropic.com>
Claude-Session: https://claude.ai/code/session_01LyAEdHGJyBVYLz5Wq2uw9J
</commit_message>
<xml_diff>
--- a/PPT_Review_of_Commando_Winning_the_Green_Beret.pptx
+++ b/PPT_Review_of_Commando_Winning_the_Green_Beret.pptx
@@ -759,7 +759,7 @@
           <a:lstStyle/>
           <a:p>
             <a:r>
-              <a:t>The distinction of the Commando lies not merely in physical toughness, but in a carefully engineered process of selection that tests determination, discipline, judgement and character under extreme fatigue. Understanding that process offers enduring insight into how elite forces are built and sustained.</a:t>
+              <a:t>Few emblems in the profession of arms carry the prestige of the Green Beret of the British Commando. The Commandos were born in the darkest days of the Second World War, as volunteer raiding forces sent to strike back at occupied Europe. They became so feared that Hitler declared captured Commandos to be outside the protection of the Geneva Conventions. Today the Royal Marines, together with the soldiers, sailors and airmen of 3 Commando Brigade, must pass the gruelling Commando Course before they may wear the beret.</a:t>
             </a:r>
           </a:p>
         </p:txBody>
@@ -829,7 +829,7 @@
           <a:lstStyle/>
           <a:p>
             <a:r>
-              <a:t>Significance: one of the most authoritative insider accounts of commando selection; shows how a respected institution turns ordinary young men into elite amphibious soldiers. Materials: entirely original, drawn from first-hand observation and the recorded words of recruits and instructors; opens doors normally closed to outsiders. Facts: test standards, numbers and dates recorded with precision; the Commandant and training teams read the chapters before publication. Clarity: logical sequence building to the Commando Tests; terms explained as they arise; organisation chart, endurance course diagram and captioned photographs. Readability: present-tense, documentary immediacy; vivid scenes and lively dialogue make it a page-turner. Mental stimulation: real dilemmas of selection, standards and integrity invite the reader to ask what he would have done. Broad-mindedness: every voice is heard, from recruit to Commandant; failures are treated with dignity. Inspiration: Jaftha’s perseverance, and leaders such as Colonel Taffinder, Major Lear and Captain Williams who take hard decisions with fairness.</a:t>
+              <a:t>On significance, the book is one of the most authoritative insider accounts of commando selection, showing how ordinary young men become elite soldiers. The materials are entirely original, drawn from first-hand observation and the recorded words of recruits and instructors. The facts are presented with precision; test standards, numbers and dates are carefully recorded, and the training staff read the chapters before publication. On clarity, the chapters follow the course in logical sequence and military terms are explained as they arise. The book is highly readable, written in the present tense with the immediacy of a live documentary. It is mentally stimulating, as it invites the reader to ask what he would have done in the instructors’ place. It is broad-minded, giving a voice to everyone from the youngest recruit to the Commandant. Finally, it is inspiring, above all through Recruit Jaftha’s perseverance and the fair, decisive leadership of his commanders.</a:t>
             </a:r>
           </a:p>
         </p:txBody>
@@ -899,7 +899,7 @@
           <a:lstStyle/>
           <a:p>
             <a:r>
-              <a:t>For military officers, these lessons underline the need to build mental toughness deliberately into training and to enforce standards of personal discipline. Soldiers, sailors and airmen who pass the same tests as the Royal Marines earn the trust of the formation they join.</a:t>
+              <a:t>First, mental resilience, not physical strength alone, decides success under cold, fatigue and stress. Second, personal administration and attention to detail are combat skills; a soldier who cannot look after his weapon and his feet cannot be relied upon. Third, common standards build trust in a joint force, a lesson directly relevant to the Ghana Armed Forces in joint operations and peace support missions.</a:t>
             </a:r>
           </a:p>
         </p:txBody>
@@ -969,7 +969,7 @@
           <a:lstStyle/>
           <a:p>
             <a:r>
-              <a:t>The instructors and commanders portrayed in the book know their men and take difficult decisions with both rigour and compassion. Detailed orders and rehearsals kept the Portland raid on track when the radios failed, while lapses of honesty were dealt with severely.</a:t>
+              <a:t>Fourth, good leadership combines firmness with fairness and judges each soldier as a whole. Fifth, thorough orders, rehearsals and brief-backs sustain operations even when communications fail. And finally, integrity is the bedrock of trust within any unit.</a:t>
             </a:r>
           </a:p>
         </p:txBody>
@@ -1039,7 +1039,427 @@
           <a:lstStyle/>
           <a:p>
             <a:r>
-              <a:t>"Commando: Winning the Green Beret" by Hugh McManners vividly captures the journey of young recruits and seasoned volunteers through one of the most demanding military courses in the world. Its clear narrative, authentic dialogue and rich illustrations make the realities of commando training accessible to all readers. The book offers valuable lessons in resilience, discipline, leadership and integrity, and is highly recommended to all officers, particularly those engaged in training and the selection of soldiers for specialist units.</a:t>
+              <a:t>In conclusion, “Commando: Winning the Green Beret” vividly captures the journey of young recruits and seasoned volunteers through one of the most demanding military courses in the world. Its clear narrative, authentic dialogue and rich illustrations make it accessible to every reader, while its lessons in resilience, discipline, leadership and integrity make it highly relevant to the professional officer. I therefore highly recommend it to all officers, particularly those involved in training and the selection of soldiers for specialist units.</a:t>
+            </a:r>
+          </a:p>
+        </p:txBody>
+      </p:sp>
+      <p:sp>
+        <p:nvSpPr>
+          <p:cNvPr id="4" name="Slide Number Placeholder 3"/>
+          <p:cNvSpPr>
+            <a:spLocks noGrp="1"/>
+          </p:cNvSpPr>
+          <p:nvPr>
+            <p:ph type="sldNum" idx="5" sz="quarter"/>
+          </p:nvPr>
+        </p:nvSpPr>
+        <p:spPr/>
+      </p:sp>
+    </p:spTree>
+  </p:cSld>
+  <p:clrMapOvr>
+    <a:masterClrMapping/>
+  </p:clrMapOvr>
+</p:notes>
+</file>
+
+<file path=ppt/notesSlides/notesSlide14.xml><?xml version="1.0" encoding="utf-8"?>
+<p:notes xmlns:a="http://schemas.openxmlformats.org/drawingml/2006/main" xmlns:p="http://schemas.openxmlformats.org/presentationml/2006/main" xmlns:r="http://schemas.openxmlformats.org/officeDocument/2006/relationships">
+  <p:cSld>
+    <p:spTree>
+      <p:nvGrpSpPr>
+        <p:cNvPr id="1" name=""/>
+        <p:cNvGrpSpPr/>
+        <p:nvPr/>
+      </p:nvGrpSpPr>
+      <p:grpSpPr>
+        <a:xfrm>
+          <a:off x="0" y="0"/>
+          <a:ext cx="0" cy="0"/>
+          <a:chOff x="0" y="0"/>
+          <a:chExt cx="0" cy="0"/>
+        </a:xfrm>
+      </p:grpSpPr>
+      <p:sp>
+        <p:nvSpPr>
+          <p:cNvPr id="2" name="Slide Image Placeholder 1"/>
+          <p:cNvSpPr>
+            <a:spLocks noGrp="1"/>
+          </p:cNvSpPr>
+          <p:nvPr>
+            <p:ph type="sldImg" idx="2"/>
+          </p:nvPr>
+        </p:nvSpPr>
+        <p:spPr/>
+      </p:sp>
+      <p:sp>
+        <p:nvSpPr>
+          <p:cNvPr id="3" name="Notes Placeholder 2"/>
+          <p:cNvSpPr>
+            <a:spLocks noGrp="1"/>
+          </p:cNvSpPr>
+          <p:nvPr>
+            <p:ph type="body" idx="3" sz="quarter"/>
+          </p:nvPr>
+        </p:nvSpPr>
+        <p:spPr/>
+        <p:txBody>
+          <a:bodyPr/>
+          <a:lstStyle/>
+          <a:p>
+            <a:r>
+              <a:t>Good morning DS, good morning colleagues. I am (rank and name). This morning I will be presenting a review of the book “Commando: Winning the Green Beret” by Hugh McManners.</a:t>
+            </a:r>
+          </a:p>
+        </p:txBody>
+      </p:sp>
+      <p:sp>
+        <p:nvSpPr>
+          <p:cNvPr id="4" name="Slide Number Placeholder 3"/>
+          <p:cNvSpPr>
+            <a:spLocks noGrp="1"/>
+          </p:cNvSpPr>
+          <p:nvPr>
+            <p:ph type="sldNum" idx="5" sz="quarter"/>
+          </p:nvPr>
+        </p:nvSpPr>
+        <p:spPr/>
+      </p:sp>
+    </p:spTree>
+  </p:cSld>
+  <p:clrMapOvr>
+    <a:masterClrMapping/>
+  </p:clrMapOvr>
+</p:notes>
+</file>
+
+<file path=ppt/notesSlides/notesSlide15.xml><?xml version="1.0" encoding="utf-8"?>
+<p:notes xmlns:a="http://schemas.openxmlformats.org/drawingml/2006/main" xmlns:p="http://schemas.openxmlformats.org/presentationml/2006/main" xmlns:r="http://schemas.openxmlformats.org/officeDocument/2006/relationships">
+  <p:cSld>
+    <p:spTree>
+      <p:nvGrpSpPr>
+        <p:cNvPr id="1" name=""/>
+        <p:cNvGrpSpPr/>
+        <p:nvPr/>
+      </p:nvGrpSpPr>
+      <p:grpSpPr>
+        <a:xfrm>
+          <a:off x="0" y="0"/>
+          <a:ext cx="0" cy="0"/>
+          <a:chOff x="0" y="0"/>
+          <a:chExt cx="0" cy="0"/>
+        </a:xfrm>
+      </p:grpSpPr>
+      <p:sp>
+        <p:nvSpPr>
+          <p:cNvPr id="2" name="Slide Image Placeholder 1"/>
+          <p:cNvSpPr>
+            <a:spLocks noGrp="1"/>
+          </p:cNvSpPr>
+          <p:nvPr>
+            <p:ph type="sldImg" idx="2"/>
+          </p:nvPr>
+        </p:nvSpPr>
+        <p:spPr/>
+      </p:sp>
+      <p:sp>
+        <p:nvSpPr>
+          <p:cNvPr id="3" name="Notes Placeholder 2"/>
+          <p:cNvSpPr>
+            <a:spLocks noGrp="1"/>
+          </p:cNvSpPr>
+          <p:nvPr>
+            <p:ph type="body" idx="3" sz="quarter"/>
+          </p:nvPr>
+        </p:nvSpPr>
+        <p:spPr/>
+        <p:txBody>
+          <a:bodyPr/>
+          <a:lstStyle/>
+          <a:p>
+            <a:r>
+              <a:t>I will begin with the introduction.</a:t>
+            </a:r>
+          </a:p>
+        </p:txBody>
+      </p:sp>
+      <p:sp>
+        <p:nvSpPr>
+          <p:cNvPr id="4" name="Slide Number Placeholder 3"/>
+          <p:cNvSpPr>
+            <a:spLocks noGrp="1"/>
+          </p:cNvSpPr>
+          <p:nvPr>
+            <p:ph type="sldNum" idx="5" sz="quarter"/>
+          </p:nvPr>
+        </p:nvSpPr>
+        <p:spPr/>
+      </p:sp>
+    </p:spTree>
+  </p:cSld>
+  <p:clrMapOvr>
+    <a:masterClrMapping/>
+  </p:clrMapOvr>
+</p:notes>
+</file>
+
+<file path=ppt/notesSlides/notesSlide16.xml><?xml version="1.0" encoding="utf-8"?>
+<p:notes xmlns:a="http://schemas.openxmlformats.org/drawingml/2006/main" xmlns:p="http://schemas.openxmlformats.org/presentationml/2006/main" xmlns:r="http://schemas.openxmlformats.org/officeDocument/2006/relationships">
+  <p:cSld>
+    <p:spTree>
+      <p:nvGrpSpPr>
+        <p:cNvPr id="1" name=""/>
+        <p:cNvGrpSpPr/>
+        <p:nvPr/>
+      </p:nvGrpSpPr>
+      <p:grpSpPr>
+        <a:xfrm>
+          <a:off x="0" y="0"/>
+          <a:ext cx="0" cy="0"/>
+          <a:chOff x="0" y="0"/>
+          <a:chExt cx="0" cy="0"/>
+        </a:xfrm>
+      </p:grpSpPr>
+      <p:sp>
+        <p:nvSpPr>
+          <p:cNvPr id="2" name="Slide Image Placeholder 1"/>
+          <p:cNvSpPr>
+            <a:spLocks noGrp="1"/>
+          </p:cNvSpPr>
+          <p:nvPr>
+            <p:ph type="sldImg" idx="2"/>
+          </p:nvPr>
+        </p:nvSpPr>
+        <p:spPr/>
+      </p:sp>
+      <p:sp>
+        <p:nvSpPr>
+          <p:cNvPr id="3" name="Notes Placeholder 2"/>
+          <p:cNvSpPr>
+            <a:spLocks noGrp="1"/>
+          </p:cNvSpPr>
+          <p:nvPr>
+            <p:ph type="body" idx="3" sz="quarter"/>
+          </p:nvPr>
+        </p:nvSpPr>
+        <p:spPr/>
+        <p:txBody>
+          <a:bodyPr/>
+          <a:lstStyle/>
+          <a:p>
+            <a:r>
+              <a:t>The aim of this presentation is to review the book “Commando: Winning the Green Beret” by Hugh McManners with the goal of assessing its scope and relevance and drawing lessons.</a:t>
+            </a:r>
+          </a:p>
+        </p:txBody>
+      </p:sp>
+      <p:sp>
+        <p:nvSpPr>
+          <p:cNvPr id="4" name="Slide Number Placeholder 3"/>
+          <p:cNvSpPr>
+            <a:spLocks noGrp="1"/>
+          </p:cNvSpPr>
+          <p:nvPr>
+            <p:ph type="sldNum" idx="5" sz="quarter"/>
+          </p:nvPr>
+        </p:nvSpPr>
+        <p:spPr/>
+      </p:sp>
+    </p:spTree>
+  </p:cSld>
+  <p:clrMapOvr>
+    <a:masterClrMapping/>
+  </p:clrMapOvr>
+</p:notes>
+</file>
+
+<file path=ppt/notesSlides/notesSlide17.xml><?xml version="1.0" encoding="utf-8"?>
+<p:notes xmlns:a="http://schemas.openxmlformats.org/drawingml/2006/main" xmlns:p="http://schemas.openxmlformats.org/presentationml/2006/main" xmlns:r="http://schemas.openxmlformats.org/officeDocument/2006/relationships">
+  <p:cSld>
+    <p:spTree>
+      <p:nvGrpSpPr>
+        <p:cNvPr id="1" name=""/>
+        <p:cNvGrpSpPr/>
+        <p:nvPr/>
+      </p:nvGrpSpPr>
+      <p:grpSpPr>
+        <a:xfrm>
+          <a:off x="0" y="0"/>
+          <a:ext cx="0" cy="0"/>
+          <a:chOff x="0" y="0"/>
+          <a:chExt cx="0" cy="0"/>
+        </a:xfrm>
+      </p:grpSpPr>
+      <p:sp>
+        <p:nvSpPr>
+          <p:cNvPr id="2" name="Slide Image Placeholder 1"/>
+          <p:cNvSpPr>
+            <a:spLocks noGrp="1"/>
+          </p:cNvSpPr>
+          <p:nvPr>
+            <p:ph type="sldImg" idx="2"/>
+          </p:nvPr>
+        </p:nvSpPr>
+        <p:spPr/>
+      </p:sp>
+      <p:sp>
+        <p:nvSpPr>
+          <p:cNvPr id="3" name="Notes Placeholder 2"/>
+          <p:cNvSpPr>
+            <a:spLocks noGrp="1"/>
+          </p:cNvSpPr>
+          <p:nvPr>
+            <p:ph type="body" idx="3" sz="quarter"/>
+          </p:nvPr>
+        </p:nvSpPr>
+        <p:spPr/>
+        <p:txBody>
+          <a:bodyPr/>
+          <a:lstStyle/>
+          <a:p>
+            <a:r>
+              <a:t>To achieve this aim, the presentation will cover the biography of the author, an overview of the book, a summary of the book, an evaluation of the book, the lessons learnt and a conclusion.</a:t>
+            </a:r>
+          </a:p>
+        </p:txBody>
+      </p:sp>
+      <p:sp>
+        <p:nvSpPr>
+          <p:cNvPr id="4" name="Slide Number Placeholder 3"/>
+          <p:cNvSpPr>
+            <a:spLocks noGrp="1"/>
+          </p:cNvSpPr>
+          <p:nvPr>
+            <p:ph type="sldNum" idx="5" sz="quarter"/>
+          </p:nvPr>
+        </p:nvSpPr>
+        <p:spPr/>
+      </p:sp>
+    </p:spTree>
+  </p:cSld>
+  <p:clrMapOvr>
+    <a:masterClrMapping/>
+  </p:clrMapOvr>
+</p:notes>
+</file>
+
+<file path=ppt/notesSlides/notesSlide18.xml><?xml version="1.0" encoding="utf-8"?>
+<p:notes xmlns:a="http://schemas.openxmlformats.org/drawingml/2006/main" xmlns:p="http://schemas.openxmlformats.org/presentationml/2006/main" xmlns:r="http://schemas.openxmlformats.org/officeDocument/2006/relationships">
+  <p:cSld>
+    <p:spTree>
+      <p:nvGrpSpPr>
+        <p:cNvPr id="1" name=""/>
+        <p:cNvGrpSpPr/>
+        <p:nvPr/>
+      </p:nvGrpSpPr>
+      <p:grpSpPr>
+        <a:xfrm>
+          <a:off x="0" y="0"/>
+          <a:ext cx="0" cy="0"/>
+          <a:chOff x="0" y="0"/>
+          <a:chExt cx="0" cy="0"/>
+        </a:xfrm>
+      </p:grpSpPr>
+      <p:sp>
+        <p:nvSpPr>
+          <p:cNvPr id="2" name="Slide Image Placeholder 1"/>
+          <p:cNvSpPr>
+            <a:spLocks noGrp="1"/>
+          </p:cNvSpPr>
+          <p:nvPr>
+            <p:ph type="sldImg" idx="2"/>
+          </p:nvPr>
+        </p:nvSpPr>
+        <p:spPr/>
+      </p:sp>
+      <p:sp>
+        <p:nvSpPr>
+          <p:cNvPr id="3" name="Notes Placeholder 2"/>
+          <p:cNvSpPr>
+            <a:spLocks noGrp="1"/>
+          </p:cNvSpPr>
+          <p:nvPr>
+            <p:ph type="body" idx="3" sz="quarter"/>
+          </p:nvPr>
+        </p:nvSpPr>
+        <p:spPr/>
+        <p:txBody>
+          <a:bodyPr/>
+          <a:lstStyle/>
+          <a:p>
+            <a:r>
+              <a:t>I will now take you through the biography of the author, Hugh McManners.</a:t>
+            </a:r>
+          </a:p>
+        </p:txBody>
+      </p:sp>
+      <p:sp>
+        <p:nvSpPr>
+          <p:cNvPr id="4" name="Slide Number Placeholder 3"/>
+          <p:cNvSpPr>
+            <a:spLocks noGrp="1"/>
+          </p:cNvSpPr>
+          <p:nvPr>
+            <p:ph type="sldNum" idx="5" sz="quarter"/>
+          </p:nvPr>
+        </p:nvSpPr>
+        <p:spPr/>
+      </p:sp>
+    </p:spTree>
+  </p:cSld>
+  <p:clrMapOvr>
+    <a:masterClrMapping/>
+  </p:clrMapOvr>
+</p:notes>
+</file>
+
+<file path=ppt/notesSlides/notesSlide19.xml><?xml version="1.0" encoding="utf-8"?>
+<p:notes xmlns:a="http://schemas.openxmlformats.org/drawingml/2006/main" xmlns:p="http://schemas.openxmlformats.org/presentationml/2006/main" xmlns:r="http://schemas.openxmlformats.org/officeDocument/2006/relationships">
+  <p:cSld>
+    <p:spTree>
+      <p:nvGrpSpPr>
+        <p:cNvPr id="1" name=""/>
+        <p:cNvGrpSpPr/>
+        <p:nvPr/>
+      </p:nvGrpSpPr>
+      <p:grpSpPr>
+        <a:xfrm>
+          <a:off x="0" y="0"/>
+          <a:ext cx="0" cy="0"/>
+          <a:chOff x="0" y="0"/>
+          <a:chExt cx="0" cy="0"/>
+        </a:xfrm>
+      </p:grpSpPr>
+      <p:sp>
+        <p:nvSpPr>
+          <p:cNvPr id="2" name="Slide Image Placeholder 1"/>
+          <p:cNvSpPr>
+            <a:spLocks noGrp="1"/>
+          </p:cNvSpPr>
+          <p:nvPr>
+            <p:ph type="sldImg" idx="2"/>
+          </p:nvPr>
+        </p:nvSpPr>
+        <p:spPr/>
+      </p:sp>
+      <p:sp>
+        <p:nvSpPr>
+          <p:cNvPr id="3" name="Notes Placeholder 2"/>
+          <p:cNvSpPr>
+            <a:spLocks noGrp="1"/>
+          </p:cNvSpPr>
+          <p:nvPr>
+            <p:ph type="body" idx="3" sz="quarter"/>
+          </p:nvPr>
+        </p:nvSpPr>
+        <p:spPr/>
+        <p:txBody>
+          <a:bodyPr/>
+          <a:lstStyle/>
+          <a:p>
+            <a:r>
+              <a:t>After the Army, he became Defence Correspondent of The Sunday Times and wrote for The Observer and The Daily Telegraph. He produced television documentaries, including the series on which this book is based, edited Command magazine and has written some fifteen books.</a:t>
             </a:r>
           </a:p>
         </p:txBody>
@@ -1109,7 +1529,567 @@
           <a:lstStyle/>
           <a:p>
             <a:r>
-              <a:t>The book grew out of a five-part television documentary which McManners devised with the producer-director Charles Thompson. It follows recruits and volunteers from the Army, Royal Navy and Royal Air Force as they battle the Final Exercise and the four Commando Tests for the right to wear the Green Beret.</a:t>
+              <a:t>This book follows two courses through the bitter winter of 1992: 638 Recruit Troop of young Royal Marines recruits, and All Arms Commando Course 4/92, made up of volunteers from the Army, the Royal Navy and the Royal Air Force. Its central message is that the essence of commando selection is mental: determination, discipline and character under extreme fatigue. Publishers Weekly described it as a “brief and arresting” account of why the Royal Marine Commandos are so highly regarded.</a:t>
+            </a:r>
+          </a:p>
+        </p:txBody>
+      </p:sp>
+      <p:sp>
+        <p:nvSpPr>
+          <p:cNvPr id="4" name="Slide Number Placeholder 3"/>
+          <p:cNvSpPr>
+            <a:spLocks noGrp="1"/>
+          </p:cNvSpPr>
+          <p:nvPr>
+            <p:ph type="sldNum" idx="5" sz="quarter"/>
+          </p:nvPr>
+        </p:nvSpPr>
+        <p:spPr/>
+      </p:sp>
+    </p:spTree>
+  </p:cSld>
+  <p:clrMapOvr>
+    <a:masterClrMapping/>
+  </p:clrMapOvr>
+</p:notes>
+</file>
+
+<file path=ppt/notesSlides/notesSlide20.xml><?xml version="1.0" encoding="utf-8"?>
+<p:notes xmlns:a="http://schemas.openxmlformats.org/drawingml/2006/main" xmlns:p="http://schemas.openxmlformats.org/presentationml/2006/main" xmlns:r="http://schemas.openxmlformats.org/officeDocument/2006/relationships">
+  <p:cSld>
+    <p:spTree>
+      <p:nvGrpSpPr>
+        <p:cNvPr id="1" name=""/>
+        <p:cNvGrpSpPr/>
+        <p:nvPr/>
+      </p:nvGrpSpPr>
+      <p:grpSpPr>
+        <a:xfrm>
+          <a:off x="0" y="0"/>
+          <a:ext cx="0" cy="0"/>
+          <a:chOff x="0" y="0"/>
+          <a:chExt cx="0" cy="0"/>
+        </a:xfrm>
+      </p:grpSpPr>
+      <p:sp>
+        <p:nvSpPr>
+          <p:cNvPr id="2" name="Slide Image Placeholder 1"/>
+          <p:cNvSpPr>
+            <a:spLocks noGrp="1"/>
+          </p:cNvSpPr>
+          <p:nvPr>
+            <p:ph type="sldImg" idx="2"/>
+          </p:nvPr>
+        </p:nvSpPr>
+        <p:spPr/>
+      </p:sp>
+      <p:sp>
+        <p:nvSpPr>
+          <p:cNvPr id="3" name="Notes Placeholder 2"/>
+          <p:cNvSpPr>
+            <a:spLocks noGrp="1"/>
+          </p:cNvSpPr>
+          <p:nvPr>
+            <p:ph type="body" idx="3" sz="quarter"/>
+          </p:nvPr>
+        </p:nvSpPr>
+        <p:spPr/>
+        <p:txBody>
+          <a:bodyPr/>
+          <a:lstStyle/>
+          <a:p>
+            <a:r>
+              <a:t>I will now give an overview of the book.</a:t>
+            </a:r>
+          </a:p>
+        </p:txBody>
+      </p:sp>
+      <p:sp>
+        <p:nvSpPr>
+          <p:cNvPr id="4" name="Slide Number Placeholder 3"/>
+          <p:cNvSpPr>
+            <a:spLocks noGrp="1"/>
+          </p:cNvSpPr>
+          <p:nvPr>
+            <p:ph type="sldNum" idx="5" sz="quarter"/>
+          </p:nvPr>
+        </p:nvSpPr>
+        <p:spPr/>
+      </p:sp>
+    </p:spTree>
+  </p:cSld>
+  <p:clrMapOvr>
+    <a:masterClrMapping/>
+  </p:clrMapOvr>
+</p:notes>
+</file>
+
+<file path=ppt/notesSlides/notesSlide21.xml><?xml version="1.0" encoding="utf-8"?>
+<p:notes xmlns:a="http://schemas.openxmlformats.org/drawingml/2006/main" xmlns:p="http://schemas.openxmlformats.org/presentationml/2006/main" xmlns:r="http://schemas.openxmlformats.org/officeDocument/2006/relationships">
+  <p:cSld>
+    <p:spTree>
+      <p:nvGrpSpPr>
+        <p:cNvPr id="1" name=""/>
+        <p:cNvGrpSpPr/>
+        <p:nvPr/>
+      </p:nvGrpSpPr>
+      <p:grpSpPr>
+        <a:xfrm>
+          <a:off x="0" y="0"/>
+          <a:ext cx="0" cy="0"/>
+          <a:chOff x="0" y="0"/>
+          <a:chExt cx="0" cy="0"/>
+        </a:xfrm>
+      </p:grpSpPr>
+      <p:sp>
+        <p:nvSpPr>
+          <p:cNvPr id="2" name="Slide Image Placeholder 1"/>
+          <p:cNvSpPr>
+            <a:spLocks noGrp="1"/>
+          </p:cNvSpPr>
+          <p:nvPr>
+            <p:ph type="sldImg" idx="2"/>
+          </p:nvPr>
+        </p:nvSpPr>
+        <p:spPr/>
+      </p:sp>
+      <p:sp>
+        <p:nvSpPr>
+          <p:cNvPr id="3" name="Notes Placeholder 2"/>
+          <p:cNvSpPr>
+            <a:spLocks noGrp="1"/>
+          </p:cNvSpPr>
+          <p:nvPr>
+            <p:ph type="body" idx="3" sz="quarter"/>
+          </p:nvPr>
+        </p:nvSpPr>
+        <p:spPr/>
+        <p:txBody>
+          <a:bodyPr/>
+          <a:lstStyle/>
+          <a:p>
+            <a:r>
+              <a:t>Moving on to the summary of the book.</a:t>
+            </a:r>
+          </a:p>
+        </p:txBody>
+      </p:sp>
+      <p:sp>
+        <p:nvSpPr>
+          <p:cNvPr id="4" name="Slide Number Placeholder 3"/>
+          <p:cNvSpPr>
+            <a:spLocks noGrp="1"/>
+          </p:cNvSpPr>
+          <p:nvPr>
+            <p:ph type="sldNum" idx="5" sz="quarter"/>
+          </p:nvPr>
+        </p:nvSpPr>
+        <p:spPr/>
+      </p:sp>
+    </p:spTree>
+  </p:cSld>
+  <p:clrMapOvr>
+    <a:masterClrMapping/>
+  </p:clrMapOvr>
+</p:notes>
+</file>
+
+<file path=ppt/notesSlides/notesSlide22.xml><?xml version="1.0" encoding="utf-8"?>
+<p:notes xmlns:a="http://schemas.openxmlformats.org/drawingml/2006/main" xmlns:p="http://schemas.openxmlformats.org/presentationml/2006/main" xmlns:r="http://schemas.openxmlformats.org/officeDocument/2006/relationships">
+  <p:cSld>
+    <p:spTree>
+      <p:nvGrpSpPr>
+        <p:cNvPr id="1" name=""/>
+        <p:cNvGrpSpPr/>
+        <p:nvPr/>
+      </p:nvGrpSpPr>
+      <p:grpSpPr>
+        <a:xfrm>
+          <a:off x="0" y="0"/>
+          <a:ext cx="0" cy="0"/>
+          <a:chOff x="0" y="0"/>
+          <a:chExt cx="0" cy="0"/>
+        </a:xfrm>
+      </p:grpSpPr>
+      <p:sp>
+        <p:nvSpPr>
+          <p:cNvPr id="2" name="Slide Image Placeholder 1"/>
+          <p:cNvSpPr>
+            <a:spLocks noGrp="1"/>
+          </p:cNvSpPr>
+          <p:nvPr>
+            <p:ph type="sldImg" idx="2"/>
+          </p:nvPr>
+        </p:nvSpPr>
+        <p:spPr/>
+      </p:sp>
+      <p:sp>
+        <p:nvSpPr>
+          <p:cNvPr id="3" name="Notes Placeholder 2"/>
+          <p:cNvSpPr>
+            <a:spLocks noGrp="1"/>
+          </p:cNvSpPr>
+          <p:nvPr>
+            <p:ph type="body" idx="3" sz="quarter"/>
+          </p:nvPr>
+        </p:nvSpPr>
+        <p:spPr/>
+        <p:txBody>
+          <a:bodyPr/>
+          <a:lstStyle/>
+          <a:p>
+            <a:r>
+              <a:t>These scenes from the book show an assault landing at Poole, Recruit Jaftha frozen at the edge of the chasm, the All Arms volunteers on Dartmoor, and two new commandos wearing the Green Beret for the first time.</a:t>
+            </a:r>
+          </a:p>
+        </p:txBody>
+      </p:sp>
+      <p:sp>
+        <p:nvSpPr>
+          <p:cNvPr id="4" name="Slide Number Placeholder 3"/>
+          <p:cNvSpPr>
+            <a:spLocks noGrp="1"/>
+          </p:cNvSpPr>
+          <p:nvPr>
+            <p:ph type="sldNum" idx="5" sz="quarter"/>
+          </p:nvPr>
+        </p:nvSpPr>
+        <p:spPr/>
+      </p:sp>
+    </p:spTree>
+  </p:cSld>
+  <p:clrMapOvr>
+    <a:masterClrMapping/>
+  </p:clrMapOvr>
+</p:notes>
+</file>
+
+<file path=ppt/notesSlides/notesSlide23.xml><?xml version="1.0" encoding="utf-8"?>
+<p:notes xmlns:a="http://schemas.openxmlformats.org/drawingml/2006/main" xmlns:p="http://schemas.openxmlformats.org/presentationml/2006/main" xmlns:r="http://schemas.openxmlformats.org/officeDocument/2006/relationships">
+  <p:cSld>
+    <p:spTree>
+      <p:nvGrpSpPr>
+        <p:cNvPr id="1" name=""/>
+        <p:cNvGrpSpPr/>
+        <p:nvPr/>
+      </p:nvGrpSpPr>
+      <p:grpSpPr>
+        <a:xfrm>
+          <a:off x="0" y="0"/>
+          <a:ext cx="0" cy="0"/>
+          <a:chOff x="0" y="0"/>
+          <a:chExt cx="0" cy="0"/>
+        </a:xfrm>
+      </p:grpSpPr>
+      <p:sp>
+        <p:nvSpPr>
+          <p:cNvPr id="2" name="Slide Image Placeholder 1"/>
+          <p:cNvSpPr>
+            <a:spLocks noGrp="1"/>
+          </p:cNvSpPr>
+          <p:nvPr>
+            <p:ph type="sldImg" idx="2"/>
+          </p:nvPr>
+        </p:nvSpPr>
+        <p:spPr/>
+      </p:sp>
+      <p:sp>
+        <p:nvSpPr>
+          <p:cNvPr id="3" name="Notes Placeholder 2"/>
+          <p:cNvSpPr>
+            <a:spLocks noGrp="1"/>
+          </p:cNvSpPr>
+          <p:nvPr>
+            <p:ph type="body" idx="3" sz="quarter"/>
+          </p:nvPr>
+        </p:nvSpPr>
+        <p:spPr/>
+        <p:txBody>
+          <a:bodyPr/>
+          <a:lstStyle/>
+          <a:p>
+            <a:r>
+              <a:t>I will now evaluate the book.</a:t>
+            </a:r>
+          </a:p>
+        </p:txBody>
+      </p:sp>
+      <p:sp>
+        <p:nvSpPr>
+          <p:cNvPr id="4" name="Slide Number Placeholder 3"/>
+          <p:cNvSpPr>
+            <a:spLocks noGrp="1"/>
+          </p:cNvSpPr>
+          <p:nvPr>
+            <p:ph type="sldNum" idx="5" sz="quarter"/>
+          </p:nvPr>
+        </p:nvSpPr>
+        <p:spPr/>
+      </p:sp>
+    </p:spTree>
+  </p:cSld>
+  <p:clrMapOvr>
+    <a:masterClrMapping/>
+  </p:clrMapOvr>
+</p:notes>
+</file>
+
+<file path=ppt/notesSlides/notesSlide24.xml><?xml version="1.0" encoding="utf-8"?>
+<p:notes xmlns:a="http://schemas.openxmlformats.org/drawingml/2006/main" xmlns:p="http://schemas.openxmlformats.org/presentationml/2006/main" xmlns:r="http://schemas.openxmlformats.org/officeDocument/2006/relationships">
+  <p:cSld>
+    <p:spTree>
+      <p:nvGrpSpPr>
+        <p:cNvPr id="1" name=""/>
+        <p:cNvGrpSpPr/>
+        <p:nvPr/>
+      </p:nvGrpSpPr>
+      <p:grpSpPr>
+        <a:xfrm>
+          <a:off x="0" y="0"/>
+          <a:ext cx="0" cy="0"/>
+          <a:chOff x="0" y="0"/>
+          <a:chExt cx="0" cy="0"/>
+        </a:xfrm>
+      </p:grpSpPr>
+      <p:sp>
+        <p:nvSpPr>
+          <p:cNvPr id="2" name="Slide Image Placeholder 1"/>
+          <p:cNvSpPr>
+            <a:spLocks noGrp="1"/>
+          </p:cNvSpPr>
+          <p:nvPr>
+            <p:ph type="sldImg" idx="2"/>
+          </p:nvPr>
+        </p:nvSpPr>
+        <p:spPr/>
+      </p:sp>
+      <p:sp>
+        <p:nvSpPr>
+          <p:cNvPr id="3" name="Notes Placeholder 2"/>
+          <p:cNvSpPr>
+            <a:spLocks noGrp="1"/>
+          </p:cNvSpPr>
+          <p:nvPr>
+            <p:ph type="body" idx="3" sz="quarter"/>
+          </p:nvPr>
+        </p:nvSpPr>
+        <p:spPr/>
+        <p:txBody>
+          <a:bodyPr/>
+          <a:lstStyle/>
+          <a:p>
+            <a:r>
+              <a:t>The book offers several lessons for us as officers.</a:t>
+            </a:r>
+          </a:p>
+        </p:txBody>
+      </p:sp>
+      <p:sp>
+        <p:nvSpPr>
+          <p:cNvPr id="4" name="Slide Number Placeholder 3"/>
+          <p:cNvSpPr>
+            <a:spLocks noGrp="1"/>
+          </p:cNvSpPr>
+          <p:nvPr>
+            <p:ph type="sldNum" idx="5" sz="quarter"/>
+          </p:nvPr>
+        </p:nvSpPr>
+        <p:spPr/>
+      </p:sp>
+    </p:spTree>
+  </p:cSld>
+  <p:clrMapOvr>
+    <a:masterClrMapping/>
+  </p:clrMapOvr>
+</p:notes>
+</file>
+
+<file path=ppt/notesSlides/notesSlide25.xml><?xml version="1.0" encoding="utf-8"?>
+<p:notes xmlns:a="http://schemas.openxmlformats.org/drawingml/2006/main" xmlns:p="http://schemas.openxmlformats.org/presentationml/2006/main" xmlns:r="http://schemas.openxmlformats.org/officeDocument/2006/relationships">
+  <p:cSld>
+    <p:spTree>
+      <p:nvGrpSpPr>
+        <p:cNvPr id="1" name=""/>
+        <p:cNvGrpSpPr/>
+        <p:nvPr/>
+      </p:nvGrpSpPr>
+      <p:grpSpPr>
+        <a:xfrm>
+          <a:off x="0" y="0"/>
+          <a:ext cx="0" cy="0"/>
+          <a:chOff x="0" y="0"/>
+          <a:chExt cx="0" cy="0"/>
+        </a:xfrm>
+      </p:grpSpPr>
+      <p:sp>
+        <p:nvSpPr>
+          <p:cNvPr id="2" name="Slide Image Placeholder 1"/>
+          <p:cNvSpPr>
+            <a:spLocks noGrp="1"/>
+          </p:cNvSpPr>
+          <p:nvPr>
+            <p:ph type="sldImg" idx="2"/>
+          </p:nvPr>
+        </p:nvSpPr>
+        <p:spPr/>
+      </p:sp>
+      <p:sp>
+        <p:nvSpPr>
+          <p:cNvPr id="3" name="Notes Placeholder 2"/>
+          <p:cNvSpPr>
+            <a:spLocks noGrp="1"/>
+          </p:cNvSpPr>
+          <p:nvPr>
+            <p:ph type="body" idx="3" sz="quarter"/>
+          </p:nvPr>
+        </p:nvSpPr>
+        <p:spPr/>
+        <p:txBody>
+          <a:bodyPr/>
+          <a:lstStyle/>
+          <a:p>
+            <a:r>
+              <a:t>Thank you for your attention.</a:t>
+            </a:r>
+          </a:p>
+        </p:txBody>
+      </p:sp>
+      <p:sp>
+        <p:nvSpPr>
+          <p:cNvPr id="4" name="Slide Number Placeholder 3"/>
+          <p:cNvSpPr>
+            <a:spLocks noGrp="1"/>
+          </p:cNvSpPr>
+          <p:nvPr>
+            <p:ph type="sldNum" idx="5" sz="quarter"/>
+          </p:nvPr>
+        </p:nvSpPr>
+        <p:spPr/>
+      </p:sp>
+    </p:spTree>
+  </p:cSld>
+  <p:clrMapOvr>
+    <a:masterClrMapping/>
+  </p:clrMapOvr>
+</p:notes>
+</file>
+
+<file path=ppt/notesSlides/notesSlide26.xml><?xml version="1.0" encoding="utf-8"?>
+<p:notes xmlns:a="http://schemas.openxmlformats.org/drawingml/2006/main" xmlns:p="http://schemas.openxmlformats.org/presentationml/2006/main" xmlns:r="http://schemas.openxmlformats.org/officeDocument/2006/relationships">
+  <p:cSld>
+    <p:spTree>
+      <p:nvGrpSpPr>
+        <p:cNvPr id="1" name=""/>
+        <p:cNvGrpSpPr/>
+        <p:nvPr/>
+      </p:nvGrpSpPr>
+      <p:grpSpPr>
+        <a:xfrm>
+          <a:off x="0" y="0"/>
+          <a:ext cx="0" cy="0"/>
+          <a:chOff x="0" y="0"/>
+          <a:chExt cx="0" cy="0"/>
+        </a:xfrm>
+      </p:grpSpPr>
+      <p:sp>
+        <p:nvSpPr>
+          <p:cNvPr id="2" name="Slide Image Placeholder 1"/>
+          <p:cNvSpPr>
+            <a:spLocks noGrp="1"/>
+          </p:cNvSpPr>
+          <p:nvPr>
+            <p:ph type="sldImg" idx="2"/>
+          </p:nvPr>
+        </p:nvSpPr>
+        <p:spPr/>
+      </p:sp>
+      <p:sp>
+        <p:nvSpPr>
+          <p:cNvPr id="3" name="Notes Placeholder 2"/>
+          <p:cNvSpPr>
+            <a:spLocks noGrp="1"/>
+          </p:cNvSpPr>
+          <p:nvPr>
+            <p:ph type="body" idx="3" sz="quarter"/>
+          </p:nvPr>
+        </p:nvSpPr>
+        <p:spPr/>
+        <p:txBody>
+          <a:bodyPr/>
+          <a:lstStyle/>
+          <a:p>
+            <a:r>
+              <a:t>These are the references used for this review.</a:t>
+            </a:r>
+          </a:p>
+        </p:txBody>
+      </p:sp>
+      <p:sp>
+        <p:nvSpPr>
+          <p:cNvPr id="4" name="Slide Number Placeholder 3"/>
+          <p:cNvSpPr>
+            <a:spLocks noGrp="1"/>
+          </p:cNvSpPr>
+          <p:nvPr>
+            <p:ph type="sldNum" idx="5" sz="quarter"/>
+          </p:nvPr>
+        </p:nvSpPr>
+        <p:spPr/>
+      </p:sp>
+    </p:spTree>
+  </p:cSld>
+  <p:clrMapOvr>
+    <a:masterClrMapping/>
+  </p:clrMapOvr>
+</p:notes>
+</file>
+
+<file path=ppt/notesSlides/notesSlide27.xml><?xml version="1.0" encoding="utf-8"?>
+<p:notes xmlns:a="http://schemas.openxmlformats.org/drawingml/2006/main" xmlns:p="http://schemas.openxmlformats.org/presentationml/2006/main" xmlns:r="http://schemas.openxmlformats.org/officeDocument/2006/relationships">
+  <p:cSld>
+    <p:spTree>
+      <p:nvGrpSpPr>
+        <p:cNvPr id="1" name=""/>
+        <p:cNvGrpSpPr/>
+        <p:nvPr/>
+      </p:nvGrpSpPr>
+      <p:grpSpPr>
+        <a:xfrm>
+          <a:off x="0" y="0"/>
+          <a:ext cx="0" cy="0"/>
+          <a:chOff x="0" y="0"/>
+          <a:chExt cx="0" cy="0"/>
+        </a:xfrm>
+      </p:grpSpPr>
+      <p:sp>
+        <p:nvSpPr>
+          <p:cNvPr id="2" name="Slide Image Placeholder 1"/>
+          <p:cNvSpPr>
+            <a:spLocks noGrp="1"/>
+          </p:cNvSpPr>
+          <p:nvPr>
+            <p:ph type="sldImg" idx="2"/>
+          </p:nvPr>
+        </p:nvSpPr>
+        <p:spPr/>
+      </p:sp>
+      <p:sp>
+        <p:nvSpPr>
+          <p:cNvPr id="3" name="Notes Placeholder 2"/>
+          <p:cNvSpPr>
+            <a:spLocks noGrp="1"/>
+          </p:cNvSpPr>
+          <p:nvPr>
+            <p:ph type="body" idx="3" sz="quarter"/>
+          </p:nvPr>
+        </p:nvSpPr>
+        <p:spPr/>
+        <p:txBody>
+          <a:bodyPr/>
+          <a:lstStyle/>
+          <a:p>
+            <a:r>
+              <a:t>DS, colleagues, I am now ready to take your questions and contributions.</a:t>
             </a:r>
           </a:p>
         </p:txBody>
@@ -1179,7 +2159,7 @@
           <a:lstStyle/>
           <a:p>
             <a:r>
-              <a:t>Joseph Hugh McManners is a former British Army officer with first-hand experience of commando soldiering. He commanded a Naval Gunfire Forward Observation Party operating with the Special Boat Service in the Falklands and was Mentioned in Despatches for service between 21 May and 15 June 1982 (Commando Veterans Archive).</a:t>
+              <a:t>Hugh McManners was born in Oxford in 1952 and raised largely in Australia. He read Geography at St Edmund Hall, Oxford, and was commissioned into the Royal Artillery in 1973. Significantly, he passed the All Arms Commando Course himself, and served five years with 148 Commando Forward Observation Battery as a commando, military parachutist and army diver. He also ran the Army’s jungle warfare school in Belize. In the Falklands War of 1982 he led a naval gunfire observation team with the Special Boat Service and was Mentioned in Despatches. He left the Army as a Major in 1989.</a:t>
             </a:r>
           </a:p>
         </p:txBody>
@@ -1249,7 +2229,7 @@
           <a:lstStyle/>
           <a:p>
             <a:r>
-              <a:t>Photographs of the author, Hugh McManners: former Royal Artillery officer, Falklands veteran, journalist, television producer and author of some fifteen books.</a:t>
+              <a:t>These are photographs of the author.</a:t>
             </a:r>
           </a:p>
         </p:txBody>
@@ -1319,7 +2299,7 @@
           <a:lstStyle/>
           <a:p>
             <a:r>
-              <a:t>His blend of combat experience, insider knowledge of the Commando Brigade and journalistic skill makes him exceptionally qualified to write on the making of a commando. Falklands Commando was one of the first eye-witness accounts of combat in the Falklands War.</a:t>
+              <a:t>These are some of his books: “Falklands Commando”, one of the first eye-witness accounts of combat in the Falklands; “The Scars of War”, a study of the psychological cost of combat; “Forgotten Voices of the Falklands”, produced with the Imperial War Museum; and the book under review. His combat experience and journalistic skill make him exceptionally qualified to write this book.</a:t>
             </a:r>
           </a:p>
         </p:txBody>
@@ -1389,7 +2369,7 @@
           <a:lstStyle/>
           <a:p>
             <a:r>
-              <a:t>The hardcover features a striking dust jacket with a colour photograph of two mud-soaked recruits wading through water, the title in bold red, and a banner announcing that it accompanies the television series. The back cover carries a silhouette of commandos at sunset with the tagline: The most feared amphibious infantry in the world.</a:t>
+              <a:t>These are the front and back covers of the book. The dust jacket shows two mud-soaked recruits wading through water during training, with the title in bold red. The back cover carries a silhouette of commandos at sunset and the tagline, “The most feared amphibious infantry in the world.”</a:t>
             </a:r>
           </a:p>
         </p:txBody>
@@ -1459,7 +2439,7 @@
           <a:lstStyle/>
           <a:p>
             <a:r>
-              <a:t>The book contains an Introduction, seven chapters and an Epilogue, with an index. It is illustrated with black-and-white photographs taken during filming, an organisation chart of Commando Forces, a diagram of the endurance course and captioned group photographs. A Penguin paperback followed in 1995 and a revised Kindle edition in 2014.</a:t>
+              <a:t>The book was published in 1994 by Network Books, an imprint of BBC Books, in London. The copy under review is the hardcover edition of 192 pages, with an Introduction, seven chapters, an Epilogue and an index. It is richly illustrated with photographs taken during filming, and it is also available in paperback and Kindle at affordable prices.</a:t>
             </a:r>
           </a:p>
         </p:txBody>
@@ -1529,7 +2509,7 @@
           <a:lstStyle/>
           <a:p>
             <a:r>
-              <a:t>Introduction: history of the Commandos and the four Commando Tests; the essence of the tests is mental. Chapter 1: All Arms Course 4/92 - dunker trainer, cliff-climbing and the death dive; only 15 of 34 remain. Chapter 2: 638 Troop learn amphibious raiding at Poole and raid the Portland breakwater fort. Chapter 3: ambushed in their lorries, then their own dawn ambush; lessons in alertness and integrity. Chapter 4: advance to contact and night yomps on Dartmoor in relentless rain, ending with a dawn assault on a Napoleonic fort.</a:t>
+              <a:t>The Introduction traces the history of the Commandos and introduces the four Commando Tests. Chapter 1 follows the All Arms volunteers through helicopter escape drills, cliff-climbing and the terrifying “death dive”, by which time only 15 of the original 34 remain. In Chapters 2 and 3, 638 Troop learn amphibious raiding at Poole, raid a fort at Portland, are ambushed in their lorries and then mount their own dawn ambush. Chapter 4 takes the troop across Dartmoor in relentless rain, ending with a dawn assault on a Napoleonic fort.</a:t>
             </a:r>
           </a:p>
         </p:txBody>
@@ -1599,7 +2579,7 @@
           <a:lstStyle/>
           <a:p>
             <a:r>
-              <a:t>Chapter 5: the training team judge each recruit by asking, "Would I be prepared to go to war with this man?"; Recruit Jaftha battles his fear of the Tarzan course chasm. Chapter 6: the endurance course, 9-mile speed march, Tarzan assault course and 30-mile march. Chapter 7: Recruit Spink wins the King’s Badge; the All Arms volunteers receive their Green Berets and the King’s Squad pass out before the First Sea Lord. Epilogue: the new commandos in Norway, Belize and Bosnia; Jaftha finally earns his Green Beret in February 1993.</a:t>
+              <a:t>In Chapter 5, the instructors judge each recruit with one question: “Would I be prepared to go to war with this man?” Chapter 6 describes the four Commando Tests: the endurance course, the 9-mile speed march, the Tarzan assault course and the 30-mile march across Dartmoor. In Chapter 7, the recruits pass out as the King’s Squad and the volunteers receive their Green Berets. The Epilogue reveals that Recruit Jaftha, who once broke his leg on the Tarzan course, finally earned his Green Beret in February 1993.</a:t>
             </a:r>
           </a:p>
         </p:txBody>

</xml_diff>